<commit_message>
Add optional EEVDF latency tuning evidence
</commit_message>
<xml_diff>
--- a/docs/competition/materials/答辩演示.pptx
+++ b/docs/competition/materials/答辩演示.pptx
@@ -2,25 +2,25 @@
 <file path=ppt/presentation.xml><?xml version="1.0" encoding="utf-8"?>
 <p:presentation xmlns:p="http://schemas.openxmlformats.org/presentationml/2006/main" firstSlideNum="1">
   <p:sldMasterIdLst>
-    <p:sldMasterId xmlns:r="http://schemas.openxmlformats.org/officeDocument/2006/relationships" id="2147483648" r:id="R4fd5a1b1ebdc443f"/>
+    <p:sldMasterId xmlns:r="http://schemas.openxmlformats.org/officeDocument/2006/relationships" id="2147483648" r:id="R697a985261ec45c1"/>
   </p:sldMasterIdLst>
   <p:notesMasterIdLst>
-    <p:notesMasterId xmlns:r="http://schemas.openxmlformats.org/officeDocument/2006/relationships" r:id="R2a9d61d6cecc4da5"/>
+    <p:notesMasterId xmlns:r="http://schemas.openxmlformats.org/officeDocument/2006/relationships" r:id="R23d7ed588e464690"/>
   </p:notesMasterIdLst>
   <p:sldIdLst>
-    <p:sldId xmlns:r="http://schemas.openxmlformats.org/officeDocument/2006/relationships" id="256" r:id="Ree1ca88bb7ff4795"/>
-    <p:sldId xmlns:r="http://schemas.openxmlformats.org/officeDocument/2006/relationships" id="257" r:id="R0144bcf0f2464c0c"/>
-    <p:sldId xmlns:r="http://schemas.openxmlformats.org/officeDocument/2006/relationships" id="258" r:id="Rb16a571137504767"/>
-    <p:sldId xmlns:r="http://schemas.openxmlformats.org/officeDocument/2006/relationships" id="259" r:id="R783582cee81e40db"/>
-    <p:sldId xmlns:r="http://schemas.openxmlformats.org/officeDocument/2006/relationships" id="260" r:id="R94dc164cf7004b51"/>
-    <p:sldId xmlns:r="http://schemas.openxmlformats.org/officeDocument/2006/relationships" id="261" r:id="R6f140cc5db9f4dd2"/>
-    <p:sldId xmlns:r="http://schemas.openxmlformats.org/officeDocument/2006/relationships" id="262" r:id="Rd67c7d35cb334ae9"/>
-    <p:sldId xmlns:r="http://schemas.openxmlformats.org/officeDocument/2006/relationships" id="263" r:id="R3dcaf368b49344b3"/>
-    <p:sldId xmlns:r="http://schemas.openxmlformats.org/officeDocument/2006/relationships" id="264" r:id="Rca031234a689421c"/>
-    <p:sldId xmlns:r="http://schemas.openxmlformats.org/officeDocument/2006/relationships" id="265" r:id="Rc6327ffabc524201"/>
-    <p:sldId xmlns:r="http://schemas.openxmlformats.org/officeDocument/2006/relationships" id="266" r:id="Rc5fe7bb265344ab4"/>
-    <p:sldId xmlns:r="http://schemas.openxmlformats.org/officeDocument/2006/relationships" id="267" r:id="R9bd69ce3328a4e61"/>
-    <p:sldId xmlns:r="http://schemas.openxmlformats.org/officeDocument/2006/relationships" id="268" r:id="Rb63c4f509aba4633"/>
+    <p:sldId xmlns:r="http://schemas.openxmlformats.org/officeDocument/2006/relationships" id="256" r:id="Rd90cf9ffa19b472e"/>
+    <p:sldId xmlns:r="http://schemas.openxmlformats.org/officeDocument/2006/relationships" id="257" r:id="R6d70758a07bd4b5a"/>
+    <p:sldId xmlns:r="http://schemas.openxmlformats.org/officeDocument/2006/relationships" id="258" r:id="R8e19b0cfe2094f68"/>
+    <p:sldId xmlns:r="http://schemas.openxmlformats.org/officeDocument/2006/relationships" id="259" r:id="Rb169d6315c4c425a"/>
+    <p:sldId xmlns:r="http://schemas.openxmlformats.org/officeDocument/2006/relationships" id="260" r:id="R3cf3ec7516604bc0"/>
+    <p:sldId xmlns:r="http://schemas.openxmlformats.org/officeDocument/2006/relationships" id="261" r:id="Rdab4931ddd42443d"/>
+    <p:sldId xmlns:r="http://schemas.openxmlformats.org/officeDocument/2006/relationships" id="262" r:id="R884824e0567a47f3"/>
+    <p:sldId xmlns:r="http://schemas.openxmlformats.org/officeDocument/2006/relationships" id="263" r:id="Rbfca09242faa42c8"/>
+    <p:sldId xmlns:r="http://schemas.openxmlformats.org/officeDocument/2006/relationships" id="264" r:id="R740f5fcd5eba4769"/>
+    <p:sldId xmlns:r="http://schemas.openxmlformats.org/officeDocument/2006/relationships" id="265" r:id="R295e89cb070b4b09"/>
+    <p:sldId xmlns:r="http://schemas.openxmlformats.org/officeDocument/2006/relationships" id="266" r:id="Re7b9b24f6ced4812"/>
+    <p:sldId xmlns:r="http://schemas.openxmlformats.org/officeDocument/2006/relationships" id="267" r:id="R860a5aa0f0484c75"/>
+    <p:sldId xmlns:r="http://schemas.openxmlformats.org/officeDocument/2006/relationships" id="268" r:id="R3f4a6f94f38046f9"/>
   </p:sldIdLst>
   <p:sldSz cx="12192000" cy="6858000"/>
   <p:notesSz cx="6858000" cy="9144000"/>
@@ -702,7 +702,7 @@
           <a:lstStyle xmlns:a="http://schemas.openxmlformats.org/drawingml/2006/main"/>
           <a:p xmlns:a="http://schemas.openxmlformats.org/drawingml/2006/main">
             <a:r>
-              <a:t>来源：docs/competition/开发设计文档.md第7节、实验结果.md。DELAY_DEQUEUE和HRTICK调优是后续方向，未作为本版已实现成果。SMP迁移、实机和应用QoS完整链路均未验证。</a:t>
+              <a:t>来源：docs/competition/调优实验.md 和 docs/competition/复现指南.md。延迟来自三轮交替启动；QoS 检查3次全通过。2 ms cap 的 QoS 比例未达原阈值。仅为 QEMU TCG 原型结果。</a:t>
             </a:r>
           </a:p>
         </p:txBody>
@@ -1332,7 +1332,7 @@
           <a:lstStyle xmlns:a="http://schemas.openxmlformats.org/drawingml/2006/main"/>
           <a:p xmlns:a="http://schemas.openxmlformats.org/drawingml/2006/main">
             <a:r>
-              <a:t>来源：docs/competition/evidence/summary.json 和6次compare日志。每场景每次300样本，图为三次启动各自p99的中位数，单位ms。TCG客户机时钟，独立CPU3。CFS的qos行不消费in_qos字段。</a:t>
+              <a:t>来源：初版 docs/competition/evidence/summary.json 和补充 evidence/latency-2026-10-30/summary.json。初版和可选 profile 分别是独立三次启动统计中位数，非同一批镜像或合并样本；误差线是逐轮范围。TCG客户机时钟，CPU3。CFS的qos行不消费in_qos字段。</a:t>
             </a:r>
           </a:p>
         </p:txBody>
@@ -1379,7 +1379,7 @@
           <p:cNvPr id="2" name="灯片编号占位符 5">
             <a:extLst xmlns:a="http://schemas.openxmlformats.org/drawingml/2006/main">
               <a:ext uri="{FF2B5EF4-FFF2-40B4-BE49-F238E27FC236}">
-                <a16:creationId xmlns:a16="http://schemas.microsoft.com/office/drawing/2014/main" id="{FDFD7019-7865-474A-AFF5-B5F14AE1EA13}"/>
+                <a16:creationId xmlns:a16="http://schemas.microsoft.com/office/drawing/2014/main" id="{1DA0D0DF-055E-4841-90E6-8EC26790DC42}"/>
               </a:ext>
             </a:extLst>
           </p:cNvPr>
@@ -1410,7 +1410,7 @@
           <p:cNvPr id="3" name="图片 7">
             <a:extLst xmlns:a="http://schemas.openxmlformats.org/drawingml/2006/main">
               <a:ext uri="{FF2B5EF4-FFF2-40B4-BE49-F238E27FC236}">
-                <a16:creationId xmlns:a16="http://schemas.microsoft.com/office/drawing/2014/main" id="{9B2046A9-62AB-4378-B20F-8B6091977CD3}"/>
+                <a16:creationId xmlns:a16="http://schemas.microsoft.com/office/drawing/2014/main" id="{AD92FB08-7273-4129-9E7A-283DFBEEDA9C}"/>
               </a:ext>
             </a:extLst>
           </p:cNvPr>
@@ -1420,7 +1420,7 @@
           <p:nvPr/>
         </p:nvPicPr>
         <p:blipFill>
-          <a:blip xmlns:r="http://schemas.openxmlformats.org/officeDocument/2006/relationships" xmlns:a="http://schemas.openxmlformats.org/drawingml/2006/main" r:embed="R2971f9c10d2d42df"/>
+          <a:blip xmlns:r="http://schemas.openxmlformats.org/officeDocument/2006/relationships" xmlns:a="http://schemas.openxmlformats.org/drawingml/2006/main" r:embed="Rf1caa60c8a68495e"/>
           <a:stretch xmlns:a="http://schemas.openxmlformats.org/drawingml/2006/main">
             <a:fillRect l="0" t="0" r="0" b="0"/>
           </a:stretch>
@@ -1440,7 +1440,7 @@
           <p:cNvPr id="5" name="文本框 14">
             <a:extLst xmlns:a="http://schemas.openxmlformats.org/drawingml/2006/main">
               <a:ext uri="{FF2B5EF4-FFF2-40B4-BE49-F238E27FC236}">
-                <a16:creationId xmlns:a16="http://schemas.microsoft.com/office/drawing/2014/main" id="{A94293E8-1B25-4C45-9200-85218F9915C5}"/>
+                <a16:creationId xmlns:a16="http://schemas.microsoft.com/office/drawing/2014/main" id="{570F19AA-DBC6-43A0-8A23-039B8587DEAD}"/>
               </a:ext>
             </a:extLst>
           </p:cNvPr>
@@ -1491,7 +1491,7 @@
           <p:cNvPr id="6" name="直接连接符 15">
             <a:extLst xmlns:a="http://schemas.openxmlformats.org/drawingml/2006/main">
               <a:ext uri="{FF2B5EF4-FFF2-40B4-BE49-F238E27FC236}">
-                <a16:creationId xmlns:a16="http://schemas.microsoft.com/office/drawing/2014/main" id="{0FED270C-602D-451F-B361-56BC1033A092}"/>
+                <a16:creationId xmlns:a16="http://schemas.microsoft.com/office/drawing/2014/main" id="{3708BD4E-B387-4CB8-B5D2-E7CD190CC2F1}"/>
               </a:ext>
             </a:extLst>
           </p:cNvPr>
@@ -1551,7 +1551,7 @@
           <p:cNvPr id="53" name="灯片编号占位符 6">
             <a:extLst xmlns:a="http://schemas.openxmlformats.org/drawingml/2006/main">
               <a:ext uri="{FF2B5EF4-FFF2-40B4-BE49-F238E27FC236}">
-                <a16:creationId xmlns:a16="http://schemas.microsoft.com/office/drawing/2014/main" id="{63C97C3D-CD22-4725-9EA5-D1617E98AB12}"/>
+                <a16:creationId xmlns:a16="http://schemas.microsoft.com/office/drawing/2014/main" id="{7F6D31BF-A3A1-466E-A15B-0D9FA3E9E606}"/>
               </a:ext>
             </a:extLst>
           </p:cNvPr>
@@ -1599,7 +1599,7 @@
           <p:cNvPr id="15" name="灯片编号占位符 5">
             <a:extLst xmlns:a="http://schemas.openxmlformats.org/drawingml/2006/main">
               <a:ext uri="{FF2B5EF4-FFF2-40B4-BE49-F238E27FC236}">
-                <a16:creationId xmlns:a16="http://schemas.microsoft.com/office/drawing/2014/main" id="{271DDD6F-B539-430C-A2C0-A5B852625FB2}"/>
+                <a16:creationId xmlns:a16="http://schemas.microsoft.com/office/drawing/2014/main" id="{DF39C8B5-B969-4AA2-868E-E071EF34B0D9}"/>
               </a:ext>
             </a:extLst>
           </p:cNvPr>
@@ -1647,7 +1647,7 @@
           <p:cNvPr id="17" name="灯片编号占位符 4">
             <a:extLst xmlns:a="http://schemas.openxmlformats.org/drawingml/2006/main">
               <a:ext uri="{FF2B5EF4-FFF2-40B4-BE49-F238E27FC236}">
-                <a16:creationId xmlns:a16="http://schemas.microsoft.com/office/drawing/2014/main" id="{B748FE9C-ADAE-4FBB-9A07-47D70FF386BF}"/>
+                <a16:creationId xmlns:a16="http://schemas.microsoft.com/office/drawing/2014/main" id="{42AEFC7F-5DEB-48D7-9599-458A7191E2A5}"/>
               </a:ext>
             </a:extLst>
           </p:cNvPr>
@@ -1719,7 +1719,7 @@
           <p:cNvPr id="8" name="图片 1">
             <a:extLst xmlns:a="http://schemas.openxmlformats.org/drawingml/2006/main">
               <a:ext uri="{FF2B5EF4-FFF2-40B4-BE49-F238E27FC236}">
-                <a16:creationId xmlns:a16="http://schemas.microsoft.com/office/drawing/2014/main" id="{8CAEEEDE-6312-46DF-AF6C-8BF401E5B997}"/>
+                <a16:creationId xmlns:a16="http://schemas.microsoft.com/office/drawing/2014/main" id="{734821DB-A291-481B-8BFF-13EC6AAD21C6}"/>
               </a:ext>
             </a:extLst>
           </p:cNvPr>
@@ -1729,7 +1729,7 @@
           <p:nvPr/>
         </p:nvPicPr>
         <p:blipFill rotWithShape="1">
-          <a:blip xmlns:r="http://schemas.openxmlformats.org/officeDocument/2006/relationships" xmlns:a="http://schemas.openxmlformats.org/drawingml/2006/main" r:embed="Rd1411550500247ab">
+          <a:blip xmlns:r="http://schemas.openxmlformats.org/officeDocument/2006/relationships" xmlns:a="http://schemas.openxmlformats.org/drawingml/2006/main" r:embed="Re7f94fc89541477c">
             <a:alphaModFix amt="20000"/>
           </a:blip>
           <a:srcRect xmlns:a="http://schemas.openxmlformats.org/drawingml/2006/main" l="0" t="0" r="0" b="13216"/>
@@ -1750,7 +1750,7 @@
           <p:cNvPr id="10" name="文本框 3">
             <a:extLst xmlns:a="http://schemas.openxmlformats.org/drawingml/2006/main">
               <a:ext uri="{FF2B5EF4-FFF2-40B4-BE49-F238E27FC236}">
-                <a16:creationId xmlns:a16="http://schemas.microsoft.com/office/drawing/2014/main" id="{7C979FF2-A0B3-46F7-8572-9CC5F266660E}"/>
+                <a16:creationId xmlns:a16="http://schemas.microsoft.com/office/drawing/2014/main" id="{B0AB0883-C878-4857-BA9E-CB483D3D1270}"/>
               </a:ext>
             </a:extLst>
           </p:cNvPr>
@@ -1809,7 +1809,7 @@
           <p:cNvPr id="11" name="直接连接符 15">
             <a:extLst xmlns:a="http://schemas.openxmlformats.org/drawingml/2006/main">
               <a:ext uri="{FF2B5EF4-FFF2-40B4-BE49-F238E27FC236}">
-                <a16:creationId xmlns:a16="http://schemas.microsoft.com/office/drawing/2014/main" id="{FEFF282B-7FC1-42C4-B142-F9E5ACE50E19}"/>
+                <a16:creationId xmlns:a16="http://schemas.microsoft.com/office/drawing/2014/main" id="{BE2A8E8D-6BAF-4112-A0FE-780E7215E0FC}"/>
               </a:ext>
             </a:extLst>
           </p:cNvPr>
@@ -1852,7 +1852,7 @@
           <p:cNvPr id="12" name="图片 9">
             <a:extLst xmlns:a="http://schemas.openxmlformats.org/drawingml/2006/main">
               <a:ext uri="{FF2B5EF4-FFF2-40B4-BE49-F238E27FC236}">
-                <a16:creationId xmlns:a16="http://schemas.microsoft.com/office/drawing/2014/main" id="{FCFACF4A-B9C9-4BC4-9186-3BB189D20711}"/>
+                <a16:creationId xmlns:a16="http://schemas.microsoft.com/office/drawing/2014/main" id="{DC25BE5D-86F6-4E0B-B0D9-173CED535E7E}"/>
               </a:ext>
             </a:extLst>
           </p:cNvPr>
@@ -1862,7 +1862,7 @@
           <p:nvPr/>
         </p:nvPicPr>
         <p:blipFill>
-          <a:blip xmlns:r="http://schemas.openxmlformats.org/officeDocument/2006/relationships" xmlns:a="http://schemas.openxmlformats.org/drawingml/2006/main" r:embed="R132be94c71e04f17">
+          <a:blip xmlns:r="http://schemas.openxmlformats.org/officeDocument/2006/relationships" xmlns:a="http://schemas.openxmlformats.org/drawingml/2006/main" r:embed="R8893bfead52646ef">
             <a:alphaModFix amt="21000"/>
           </a:blip>
           <a:srcRect xmlns:a="http://schemas.openxmlformats.org/drawingml/2006/main" l="0" t="0" r="0" b="0"/>
@@ -1883,7 +1883,7 @@
           <p:cNvPr id="13" name="图片 4">
             <a:extLst xmlns:a="http://schemas.openxmlformats.org/drawingml/2006/main">
               <a:ext uri="{FF2B5EF4-FFF2-40B4-BE49-F238E27FC236}">
-                <a16:creationId xmlns:a16="http://schemas.microsoft.com/office/drawing/2014/main" id="{39F192FB-C697-4A4A-B855-96911F28D181}"/>
+                <a16:creationId xmlns:a16="http://schemas.microsoft.com/office/drawing/2014/main" id="{D9B9C9C0-CB54-42B3-A957-56BCC84BE1CF}"/>
               </a:ext>
             </a:extLst>
           </p:cNvPr>
@@ -1893,7 +1893,7 @@
           <p:nvPr/>
         </p:nvPicPr>
         <p:blipFill>
-          <a:blip xmlns:r="http://schemas.openxmlformats.org/officeDocument/2006/relationships" xmlns:a="http://schemas.openxmlformats.org/drawingml/2006/main" r:embed="R5552cb3459604012"/>
+          <a:blip xmlns:r="http://schemas.openxmlformats.org/officeDocument/2006/relationships" xmlns:a="http://schemas.openxmlformats.org/drawingml/2006/main" r:embed="Rb99fec3f00024b58"/>
           <a:stretch xmlns:a="http://schemas.openxmlformats.org/drawingml/2006/main">
             <a:fillRect l="0" t="0" r="0" b="0"/>
           </a:stretch>
@@ -1939,7 +1939,7 @@
           <p:cNvPr id="20" name="灯片编号占位符 5">
             <a:extLst xmlns:a="http://schemas.openxmlformats.org/drawingml/2006/main">
               <a:ext uri="{FF2B5EF4-FFF2-40B4-BE49-F238E27FC236}">
-                <a16:creationId xmlns:a16="http://schemas.microsoft.com/office/drawing/2014/main" id="{03339691-B813-4DB5-9BAF-41FD3415C6B6}"/>
+                <a16:creationId xmlns:a16="http://schemas.microsoft.com/office/drawing/2014/main" id="{1D014BEF-03B6-4D13-86C1-A0BFED9412EF}"/>
               </a:ext>
             </a:extLst>
           </p:cNvPr>
@@ -2008,7 +2008,7 @@
           <p:cNvPr id="22" name="灯片编号占位符 5">
             <a:extLst xmlns:a="http://schemas.openxmlformats.org/drawingml/2006/main">
               <a:ext uri="{FF2B5EF4-FFF2-40B4-BE49-F238E27FC236}">
-                <a16:creationId xmlns:a16="http://schemas.microsoft.com/office/drawing/2014/main" id="{1B522E65-2B81-4A4E-A9DC-772ED3F72495}"/>
+                <a16:creationId xmlns:a16="http://schemas.microsoft.com/office/drawing/2014/main" id="{320EA5B0-DF4F-4BF1-B2B3-11E04E5737A7}"/>
               </a:ext>
             </a:extLst>
           </p:cNvPr>
@@ -2068,7 +2068,7 @@
           <p:cNvPr id="25" name="文本框 14">
             <a:extLst xmlns:a="http://schemas.openxmlformats.org/drawingml/2006/main">
               <a:ext uri="{FF2B5EF4-FFF2-40B4-BE49-F238E27FC236}">
-                <a16:creationId xmlns:a16="http://schemas.microsoft.com/office/drawing/2014/main" id="{32E720B5-1C0E-4507-949F-F50252AC88FC}"/>
+                <a16:creationId xmlns:a16="http://schemas.microsoft.com/office/drawing/2014/main" id="{549FC1FB-301A-4B00-B48B-73DBE0070DD6}"/>
               </a:ext>
             </a:extLst>
           </p:cNvPr>
@@ -2127,7 +2127,7 @@
           <p:cNvPr id="26" name="直接连接符 15">
             <a:extLst xmlns:a="http://schemas.openxmlformats.org/drawingml/2006/main">
               <a:ext uri="{FF2B5EF4-FFF2-40B4-BE49-F238E27FC236}">
-                <a16:creationId xmlns:a16="http://schemas.microsoft.com/office/drawing/2014/main" id="{64115C69-22DB-4FEE-BBFF-BC554B7859B8}"/>
+                <a16:creationId xmlns:a16="http://schemas.microsoft.com/office/drawing/2014/main" id="{4704830B-BC33-4822-A8B6-F5A958994C32}"/>
               </a:ext>
             </a:extLst>
           </p:cNvPr>
@@ -2170,7 +2170,7 @@
           <p:cNvPr id="27" name="灯片编号占位符 5">
             <a:extLst xmlns:a="http://schemas.openxmlformats.org/drawingml/2006/main">
               <a:ext uri="{FF2B5EF4-FFF2-40B4-BE49-F238E27FC236}">
-                <a16:creationId xmlns:a16="http://schemas.microsoft.com/office/drawing/2014/main" id="{A5D0F26D-5FAF-4F2A-AF53-87DB3DD7F044}"/>
+                <a16:creationId xmlns:a16="http://schemas.microsoft.com/office/drawing/2014/main" id="{5F75DE75-BF45-432D-B6D8-C344900D7946}"/>
               </a:ext>
             </a:extLst>
           </p:cNvPr>
@@ -2215,7 +2215,7 @@
           <p:cNvPr id="28" name="文本占位符 9">
             <a:extLst xmlns:a="http://schemas.openxmlformats.org/drawingml/2006/main">
               <a:ext uri="{FF2B5EF4-FFF2-40B4-BE49-F238E27FC236}">
-                <a16:creationId xmlns:a16="http://schemas.microsoft.com/office/drawing/2014/main" id="{5C174BB0-39AA-4645-BD6E-349639A751C2}"/>
+                <a16:creationId xmlns:a16="http://schemas.microsoft.com/office/drawing/2014/main" id="{801839BF-5DA8-4EA1-B863-9E7FCE1F5687}"/>
               </a:ext>
             </a:extLst>
           </p:cNvPr>
@@ -2266,7 +2266,7 @@
           <p:cNvPr id="29" name="图片 1">
             <a:extLst xmlns:a="http://schemas.openxmlformats.org/drawingml/2006/main">
               <a:ext uri="{FF2B5EF4-FFF2-40B4-BE49-F238E27FC236}">
-                <a16:creationId xmlns:a16="http://schemas.microsoft.com/office/drawing/2014/main" id="{EB8B3D28-EAAB-41EE-B312-A15A135EDB3F}"/>
+                <a16:creationId xmlns:a16="http://schemas.microsoft.com/office/drawing/2014/main" id="{CFDED660-76C3-4C34-A999-96084FD5974D}"/>
               </a:ext>
             </a:extLst>
           </p:cNvPr>
@@ -2276,7 +2276,7 @@
           <p:nvPr/>
         </p:nvPicPr>
         <p:blipFill>
-          <a:blip xmlns:r="http://schemas.openxmlformats.org/officeDocument/2006/relationships" xmlns:a="http://schemas.openxmlformats.org/drawingml/2006/main" r:embed="Rcb0ac51a2c334685"/>
+          <a:blip xmlns:r="http://schemas.openxmlformats.org/officeDocument/2006/relationships" xmlns:a="http://schemas.openxmlformats.org/drawingml/2006/main" r:embed="R248bc39348224832"/>
           <a:stretch xmlns:a="http://schemas.openxmlformats.org/drawingml/2006/main">
             <a:fillRect l="0" t="0" r="0" b="0"/>
           </a:stretch>
@@ -2296,7 +2296,7 @@
           <p:cNvPr id="30" name="矩形 3">
             <a:extLst xmlns:a="http://schemas.openxmlformats.org/drawingml/2006/main">
               <a:ext uri="{FF2B5EF4-FFF2-40B4-BE49-F238E27FC236}">
-                <a16:creationId xmlns:a16="http://schemas.microsoft.com/office/drawing/2014/main" id="{E3BD3000-0660-4ED9-97CE-472E2D48CCC1}"/>
+                <a16:creationId xmlns:a16="http://schemas.microsoft.com/office/drawing/2014/main" id="{7F38C00A-A268-48B9-AF84-E3F4EC78E197}"/>
               </a:ext>
             </a:extLst>
           </p:cNvPr>
@@ -2378,7 +2378,7 @@
           <p:cNvPr id="32" name="灯片编号占位符 6">
             <a:extLst xmlns:a="http://schemas.openxmlformats.org/drawingml/2006/main">
               <a:ext uri="{FF2B5EF4-FFF2-40B4-BE49-F238E27FC236}">
-                <a16:creationId xmlns:a16="http://schemas.microsoft.com/office/drawing/2014/main" id="{1453CF9D-5ACF-4BDC-8C03-2CF9F27F515B}"/>
+                <a16:creationId xmlns:a16="http://schemas.microsoft.com/office/drawing/2014/main" id="{ECAD8386-9891-4CC2-B898-852042382A51}"/>
               </a:ext>
             </a:extLst>
           </p:cNvPr>
@@ -2418,7 +2418,7 @@
           <p:cNvPr id="33" name="图片 3">
             <a:extLst xmlns:a="http://schemas.openxmlformats.org/drawingml/2006/main">
               <a:ext uri="{FF2B5EF4-FFF2-40B4-BE49-F238E27FC236}">
-                <a16:creationId xmlns:a16="http://schemas.microsoft.com/office/drawing/2014/main" id="{90847AA4-4DBD-4854-89D5-BB844753543D}"/>
+                <a16:creationId xmlns:a16="http://schemas.microsoft.com/office/drawing/2014/main" id="{7B3F8566-A0C7-4C4C-991E-425BD2B24E15}"/>
               </a:ext>
             </a:extLst>
           </p:cNvPr>
@@ -2428,7 +2428,7 @@
           <p:nvPr/>
         </p:nvPicPr>
         <p:blipFill rotWithShape="1">
-          <a:blip xmlns:r="http://schemas.openxmlformats.org/officeDocument/2006/relationships" xmlns:a="http://schemas.openxmlformats.org/drawingml/2006/main" r:embed="R9292d0b9edcb417b">
+          <a:blip xmlns:r="http://schemas.openxmlformats.org/officeDocument/2006/relationships" xmlns:a="http://schemas.openxmlformats.org/drawingml/2006/main" r:embed="R43c67d3c3e384af6">
             <a:alphaModFix amt="35000"/>
             <a:biLevel thresh="25000"/>
           </a:blip>
@@ -2450,7 +2450,7 @@
           <p:cNvPr id="35" name="文本框 10">
             <a:extLst xmlns:a="http://schemas.openxmlformats.org/drawingml/2006/main">
               <a:ext uri="{FF2B5EF4-FFF2-40B4-BE49-F238E27FC236}">
-                <a16:creationId xmlns:a16="http://schemas.microsoft.com/office/drawing/2014/main" id="{8EAAF035-1430-4A0B-82EF-4A38C797FCA0}"/>
+                <a16:creationId xmlns:a16="http://schemas.microsoft.com/office/drawing/2014/main" id="{1848BC71-0B02-49F6-81A9-8CE3D456FE76}"/>
               </a:ext>
             </a:extLst>
           </p:cNvPr>
@@ -2509,7 +2509,7 @@
           <p:cNvPr id="36" name="直接连接符 15">
             <a:extLst xmlns:a="http://schemas.openxmlformats.org/drawingml/2006/main">
               <a:ext uri="{FF2B5EF4-FFF2-40B4-BE49-F238E27FC236}">
-                <a16:creationId xmlns:a16="http://schemas.microsoft.com/office/drawing/2014/main" id="{DBBD4830-07DB-4AFA-A4C4-9B9DCA58ED90}"/>
+                <a16:creationId xmlns:a16="http://schemas.microsoft.com/office/drawing/2014/main" id="{93225DBE-F4BD-4A87-9E43-E18B30C75DC4}"/>
               </a:ext>
             </a:extLst>
           </p:cNvPr>
@@ -2552,7 +2552,7 @@
           <p:cNvPr id="37" name="图片 4">
             <a:extLst xmlns:a="http://schemas.openxmlformats.org/drawingml/2006/main">
               <a:ext uri="{FF2B5EF4-FFF2-40B4-BE49-F238E27FC236}">
-                <a16:creationId xmlns:a16="http://schemas.microsoft.com/office/drawing/2014/main" id="{267401BC-C9BF-4E3C-80B3-041E0546B778}"/>
+                <a16:creationId xmlns:a16="http://schemas.microsoft.com/office/drawing/2014/main" id="{EC7541E6-BB7C-405E-A350-9ECB25D9948B}"/>
               </a:ext>
             </a:extLst>
           </p:cNvPr>
@@ -2562,7 +2562,7 @@
           <p:nvPr/>
         </p:nvPicPr>
         <p:blipFill>
-          <a:blip xmlns:r="http://schemas.openxmlformats.org/officeDocument/2006/relationships" xmlns:a="http://schemas.openxmlformats.org/drawingml/2006/main" r:embed="Rf1c8d1132ec2475b"/>
+          <a:blip xmlns:r="http://schemas.openxmlformats.org/officeDocument/2006/relationships" xmlns:a="http://schemas.openxmlformats.org/drawingml/2006/main" r:embed="R915a75f536a1416d"/>
           <a:stretch xmlns:a="http://schemas.openxmlformats.org/drawingml/2006/main">
             <a:fillRect l="0" t="0" r="0" b="0"/>
           </a:stretch>
@@ -2606,7 +2606,7 @@
           <p:cNvPr id="39" name="灯片编号占位符 8">
             <a:extLst xmlns:a="http://schemas.openxmlformats.org/drawingml/2006/main">
               <a:ext uri="{FF2B5EF4-FFF2-40B4-BE49-F238E27FC236}">
-                <a16:creationId xmlns:a16="http://schemas.microsoft.com/office/drawing/2014/main" id="{5558D137-1AC1-44BA-97BD-F3EC7FBB350E}"/>
+                <a16:creationId xmlns:a16="http://schemas.microsoft.com/office/drawing/2014/main" id="{734EC866-C657-4676-8FFC-48582120D02B}"/>
               </a:ext>
             </a:extLst>
           </p:cNvPr>
@@ -2646,7 +2646,7 @@
           <p:cNvPr id="41" name="文本框 2">
             <a:extLst xmlns:a="http://schemas.openxmlformats.org/drawingml/2006/main">
               <a:ext uri="{FF2B5EF4-FFF2-40B4-BE49-F238E27FC236}">
-                <a16:creationId xmlns:a16="http://schemas.microsoft.com/office/drawing/2014/main" id="{D4860D45-0093-479A-81FD-817F0E751EDD}"/>
+                <a16:creationId xmlns:a16="http://schemas.microsoft.com/office/drawing/2014/main" id="{14BD5C80-9B61-46AA-BA1B-994F438D86BB}"/>
               </a:ext>
             </a:extLst>
           </p:cNvPr>
@@ -2705,7 +2705,7 @@
           <p:cNvPr id="42" name="直接连接符 15">
             <a:extLst xmlns:a="http://schemas.openxmlformats.org/drawingml/2006/main">
               <a:ext uri="{FF2B5EF4-FFF2-40B4-BE49-F238E27FC236}">
-                <a16:creationId xmlns:a16="http://schemas.microsoft.com/office/drawing/2014/main" id="{37B71A72-A213-43C9-AAF2-FC564D460B75}"/>
+                <a16:creationId xmlns:a16="http://schemas.microsoft.com/office/drawing/2014/main" id="{55498146-14CC-43F2-AB53-B6105FECE158}"/>
               </a:ext>
             </a:extLst>
           </p:cNvPr>
@@ -2748,7 +2748,7 @@
           <p:cNvPr id="43" name="矩形 9">
             <a:extLst xmlns:a="http://schemas.openxmlformats.org/drawingml/2006/main">
               <a:ext uri="{FF2B5EF4-FFF2-40B4-BE49-F238E27FC236}">
-                <a16:creationId xmlns:a16="http://schemas.microsoft.com/office/drawing/2014/main" id="{E7033765-731A-42EA-B404-A18D74AC9D36}"/>
+                <a16:creationId xmlns:a16="http://schemas.microsoft.com/office/drawing/2014/main" id="{18B735AC-8C91-4C7A-9082-F8C8F39E2EE5}"/>
               </a:ext>
             </a:extLst>
           </p:cNvPr>
@@ -2810,7 +2810,7 @@
           <p:cNvPr id="44" name="文本框 10">
             <a:extLst xmlns:a="http://schemas.openxmlformats.org/drawingml/2006/main">
               <a:ext uri="{FF2B5EF4-FFF2-40B4-BE49-F238E27FC236}">
-                <a16:creationId xmlns:a16="http://schemas.microsoft.com/office/drawing/2014/main" id="{F9E8FDAF-3343-4F03-83F4-CFCF416A11FE}"/>
+                <a16:creationId xmlns:a16="http://schemas.microsoft.com/office/drawing/2014/main" id="{E18B16A9-61E9-4B72-8010-74B28FFF33C7}"/>
               </a:ext>
             </a:extLst>
           </p:cNvPr>
@@ -2888,7 +2888,7 @@
           <p:cNvPr id="46" name="灯片编号占位符 4">
             <a:extLst xmlns:a="http://schemas.openxmlformats.org/drawingml/2006/main">
               <a:ext uri="{FF2B5EF4-FFF2-40B4-BE49-F238E27FC236}">
-                <a16:creationId xmlns:a16="http://schemas.microsoft.com/office/drawing/2014/main" id="{5DBA3FE6-7C96-442A-98C1-DD1065F1102F}"/>
+                <a16:creationId xmlns:a16="http://schemas.microsoft.com/office/drawing/2014/main" id="{4F5F05E8-2E53-48DD-9B93-39671932E4D1}"/>
               </a:ext>
             </a:extLst>
           </p:cNvPr>
@@ -2928,7 +2928,7 @@
           <p:cNvPr id="48" name="文本框 6">
             <a:extLst xmlns:a="http://schemas.openxmlformats.org/drawingml/2006/main">
               <a:ext uri="{FF2B5EF4-FFF2-40B4-BE49-F238E27FC236}">
-                <a16:creationId xmlns:a16="http://schemas.microsoft.com/office/drawing/2014/main" id="{DFDFBF20-0075-4C07-89C5-197DA1FEF578}"/>
+                <a16:creationId xmlns:a16="http://schemas.microsoft.com/office/drawing/2014/main" id="{7DFFDA0A-2A4C-4955-9A5A-771BCCD77349}"/>
               </a:ext>
             </a:extLst>
           </p:cNvPr>
@@ -2987,7 +2987,7 @@
           <p:cNvPr id="49" name="直接连接符 7">
             <a:extLst xmlns:a="http://schemas.openxmlformats.org/drawingml/2006/main">
               <a:ext uri="{FF2B5EF4-FFF2-40B4-BE49-F238E27FC236}">
-                <a16:creationId xmlns:a16="http://schemas.microsoft.com/office/drawing/2014/main" id="{851AA89B-9E2D-47DB-931C-144065C6FB2B}"/>
+                <a16:creationId xmlns:a16="http://schemas.microsoft.com/office/drawing/2014/main" id="{A06D3CFF-27F1-4153-9D3C-8C95E0302302}"/>
               </a:ext>
             </a:extLst>
           </p:cNvPr>
@@ -3047,7 +3047,7 @@
           <p:cNvPr id="51" name="灯片编号占位符 3">
             <a:extLst xmlns:a="http://schemas.openxmlformats.org/drawingml/2006/main">
               <a:ext uri="{FF2B5EF4-FFF2-40B4-BE49-F238E27FC236}">
-                <a16:creationId xmlns:a16="http://schemas.microsoft.com/office/drawing/2014/main" id="{2F1B2B6D-FAEC-4601-9C9F-FC628CA09F53}"/>
+                <a16:creationId xmlns:a16="http://schemas.microsoft.com/office/drawing/2014/main" id="{C3331948-ABA2-4870-B839-B1B9C37C9743}"/>
               </a:ext>
             </a:extLst>
           </p:cNvPr>
@@ -3110,7 +3110,7 @@
           <p:cNvPr id="2" name="灯片编号占位符 5">
             <a:extLst xmlns:a="http://schemas.openxmlformats.org/drawingml/2006/main">
               <a:ext uri="{FF2B5EF4-FFF2-40B4-BE49-F238E27FC236}">
-                <a16:creationId xmlns:a16="http://schemas.microsoft.com/office/drawing/2014/main" id="{6DB31B94-06A9-418D-999B-8BB96E90E18E}"/>
+                <a16:creationId xmlns:a16="http://schemas.microsoft.com/office/drawing/2014/main" id="{37EDE9A1-4731-411A-8350-E0B63DC70C35}"/>
               </a:ext>
             </a:extLst>
           </p:cNvPr>
@@ -3162,19 +3162,19 @@
   </p:cSld>
   <p:clrMap bg1="lt1" tx1="dk1" bg2="lt2" tx2="dk2" accent1="accent1" accent2="accent2" accent3="accent3" accent4="accent4" accent5="accent5" accent6="accent6" hlink="hlink" folHlink="folHlink"/>
   <p:sldLayoutIdLst>
-    <p:sldLayoutId xmlns:r="http://schemas.openxmlformats.org/officeDocument/2006/relationships" id="2147483649" r:id="R2dee0f497535409d"/>
-    <p:sldLayoutId xmlns:r="http://schemas.openxmlformats.org/officeDocument/2006/relationships" id="2147483650" r:id="R5c5eddb741d346d7"/>
-    <p:sldLayoutId xmlns:r="http://schemas.openxmlformats.org/officeDocument/2006/relationships" id="2147483651" r:id="Re04ac461b26d4fcb"/>
-    <p:sldLayoutId xmlns:r="http://schemas.openxmlformats.org/officeDocument/2006/relationships" id="2147483652" r:id="Rb796042cf92e470b"/>
-    <p:sldLayoutId xmlns:r="http://schemas.openxmlformats.org/officeDocument/2006/relationships" id="2147483653" r:id="R779f4c8f882543fe"/>
-    <p:sldLayoutId xmlns:r="http://schemas.openxmlformats.org/officeDocument/2006/relationships" id="2147483654" r:id="R8df34a03c59c45a0"/>
-    <p:sldLayoutId xmlns:r="http://schemas.openxmlformats.org/officeDocument/2006/relationships" id="2147483655" r:id="Re762a500f3f24c51"/>
-    <p:sldLayoutId xmlns:r="http://schemas.openxmlformats.org/officeDocument/2006/relationships" id="2147483656" r:id="R0b5a90b94e8c4ea7"/>
-    <p:sldLayoutId xmlns:r="http://schemas.openxmlformats.org/officeDocument/2006/relationships" id="2147483657" r:id="R7b79908e9d574490"/>
-    <p:sldLayoutId xmlns:r="http://schemas.openxmlformats.org/officeDocument/2006/relationships" id="2147483658" r:id="Rfb5b75f41e2b443b"/>
-    <p:sldLayoutId xmlns:r="http://schemas.openxmlformats.org/officeDocument/2006/relationships" id="2147483659" r:id="R1a1e91b2406f4d7c"/>
-    <p:sldLayoutId xmlns:r="http://schemas.openxmlformats.org/officeDocument/2006/relationships" id="2147483660" r:id="Rb86d9267eed64590"/>
-    <p:sldLayoutId xmlns:r="http://schemas.openxmlformats.org/officeDocument/2006/relationships" id="2147483661" r:id="Rc4c86d880f5346e3"/>
+    <p:sldLayoutId xmlns:r="http://schemas.openxmlformats.org/officeDocument/2006/relationships" id="2147483649" r:id="R7aa049648a6a4e60"/>
+    <p:sldLayoutId xmlns:r="http://schemas.openxmlformats.org/officeDocument/2006/relationships" id="2147483650" r:id="R686dd8eaadd2436f"/>
+    <p:sldLayoutId xmlns:r="http://schemas.openxmlformats.org/officeDocument/2006/relationships" id="2147483651" r:id="R59bed0176eac4b92"/>
+    <p:sldLayoutId xmlns:r="http://schemas.openxmlformats.org/officeDocument/2006/relationships" id="2147483652" r:id="R66c3a4dc32ef4acc"/>
+    <p:sldLayoutId xmlns:r="http://schemas.openxmlformats.org/officeDocument/2006/relationships" id="2147483653" r:id="R85bbf24a987841d5"/>
+    <p:sldLayoutId xmlns:r="http://schemas.openxmlformats.org/officeDocument/2006/relationships" id="2147483654" r:id="R7a58f3fce72a4c7f"/>
+    <p:sldLayoutId xmlns:r="http://schemas.openxmlformats.org/officeDocument/2006/relationships" id="2147483655" r:id="Rf512c2bae6c44e92"/>
+    <p:sldLayoutId xmlns:r="http://schemas.openxmlformats.org/officeDocument/2006/relationships" id="2147483656" r:id="R6280197de8d245a0"/>
+    <p:sldLayoutId xmlns:r="http://schemas.openxmlformats.org/officeDocument/2006/relationships" id="2147483657" r:id="Rfd41d5176cbb45fd"/>
+    <p:sldLayoutId xmlns:r="http://schemas.openxmlformats.org/officeDocument/2006/relationships" id="2147483658" r:id="R7ed23b4716514191"/>
+    <p:sldLayoutId xmlns:r="http://schemas.openxmlformats.org/officeDocument/2006/relationships" id="2147483659" r:id="R79d03a532bcb44a8"/>
+    <p:sldLayoutId xmlns:r="http://schemas.openxmlformats.org/officeDocument/2006/relationships" id="2147483660" r:id="Rcd64a931a5ab44ce"/>
+    <p:sldLayoutId xmlns:r="http://schemas.openxmlformats.org/officeDocument/2006/relationships" id="2147483661" r:id="R97c709206c18420e"/>
   </p:sldLayoutIdLst>
   <p:hf hdr="0" ftr="0" dt="0"/>
   <p:txStyles>
@@ -3657,7 +3657,7 @@
           <c:idx val="0"/>
           <c:order val="0"/>
           <c:tx>
-            <c:v>CFS</c:v>
+            <c:v>CFS 初版</c:v>
           </c:tx>
           <c:spPr>
             <a:solidFill xmlns:a="http://schemas.openxmlformats.org/drawingml/2006/main">
@@ -3705,7 +3705,7 @@
           <c:idx val="1"/>
           <c:order val="1"/>
           <c:tx>
-            <c:v>EEVDF</c:v>
+            <c:v>EEVDF 初版</c:v>
           </c:tx>
           <c:spPr>
             <a:solidFill xmlns:a="http://schemas.openxmlformats.org/drawingml/2006/main">
@@ -3744,6 +3744,54 @@
                 </c:pt>
                 <c:pt idx="2">
                   <c:v>15.627952</c:v>
+                </c:pt>
+              </c:numCache>
+            </c:numRef>
+          </c:val>
+        </c:ser>
+        <c:ser>
+          <c:idx val="2"/>
+          <c:order val="2"/>
+          <c:tx>
+            <c:v>4 ms + HRTICK</c:v>
+          </c:tx>
+          <c:spPr>
+            <a:solidFill xmlns:a="http://schemas.openxmlformats.org/drawingml/2006/main">
+              <a:srgbClr val="23845A"/>
+            </a:solidFill>
+          </c:spPr>
+          <c:invertIfNegative val="0"/>
+          <c:cat>
+            <c:strRef>
+              <c:f>'Chart Data'!$E$2:$E$4</c:f>
+              <c:strCache>
+                <c:ptCount val="3"/>
+                <c:pt idx="0">
+                  <c:v>1 个忙等任务</c:v>
+                </c:pt>
+                <c:pt idx="1">
+                  <c:v>4 个忙等任务</c:v>
+                </c:pt>
+                <c:pt idx="2">
+                  <c:v>4 个忙等任务加 QoS</c:v>
+                </c:pt>
+              </c:strCache>
+            </c:strRef>
+          </c:cat>
+          <c:val>
+            <c:numRef>
+              <c:f>'Chart Data'!$F$2:$F$4</c:f>
+              <c:numCache>
+                <c:formatCode>0</c:formatCode>
+                <c:ptCount val="3"/>
+                <c:pt idx="0">
+                  <c:v>4.192512</c:v>
+                </c:pt>
+                <c:pt idx="1">
+                  <c:v>9.56264</c:v>
+                </c:pt>
+                <c:pt idx="2">
+                  <c:v>9.474016</c:v>
                 </c:pt>
               </c:numCache>
             </c:numRef>
@@ -3908,7 +3956,7 @@
           <p:cNvPr id="2" name="文本框 4">
             <a:extLst xmlns:a="http://schemas.openxmlformats.org/drawingml/2006/main">
               <a:ext uri="{FF2B5EF4-FFF2-40B4-BE49-F238E27FC236}">
-                <a16:creationId xmlns:a16="http://schemas.microsoft.com/office/drawing/2014/main" id="{F26266E7-1CFD-45B9-B237-1BB389642BF8}"/>
+                <a16:creationId xmlns:a16="http://schemas.microsoft.com/office/drawing/2014/main" id="{110244E1-8587-4FC2-96A2-D3ADF1BD7E69}"/>
               </a:ext>
             </a:extLst>
           </p:cNvPr>
@@ -4106,7 +4154,7 @@
           <p:cNvPr id="3" name="文本框 6">
             <a:extLst xmlns:a="http://schemas.openxmlformats.org/drawingml/2006/main">
               <a:ext uri="{FF2B5EF4-FFF2-40B4-BE49-F238E27FC236}">
-                <a16:creationId xmlns:a16="http://schemas.microsoft.com/office/drawing/2014/main" id="{3D574E9C-CF93-40AA-9205-D9AF2BF31EF9}"/>
+                <a16:creationId xmlns:a16="http://schemas.microsoft.com/office/drawing/2014/main" id="{1B8F6E65-7B83-4387-B45A-243717C0AA65}"/>
               </a:ext>
             </a:extLst>
           </p:cNvPr>
@@ -4278,7 +4326,7 @@
           <p:cNvPr id="4" name="文本框 10">
             <a:extLst xmlns:a="http://schemas.openxmlformats.org/drawingml/2006/main">
               <a:ext uri="{FF2B5EF4-FFF2-40B4-BE49-F238E27FC236}">
-                <a16:creationId xmlns:a16="http://schemas.microsoft.com/office/drawing/2014/main" id="{E241ED33-DE35-4509-B879-C1C186060B7A}"/>
+                <a16:creationId xmlns:a16="http://schemas.microsoft.com/office/drawing/2014/main" id="{31A478F9-7581-45F7-A066-AA3AC7A9F6C6}"/>
               </a:ext>
             </a:extLst>
           </p:cNvPr>
@@ -4448,7 +4496,7 @@
     </p:spTree>
     <p:extLst>
       <p:ext uri="{BB962C8B-B14F-4D97-AF65-F5344CB8AC3E}">
-        <p14:creationId xmlns:p14="http://schemas.microsoft.com/office/powerpoint/2010/main" val="921005186"/>
+        <p14:creationId xmlns:p14="http://schemas.microsoft.com/office/powerpoint/2010/main" val="307924385"/>
       </p:ext>
     </p:extLst>
   </p:cSld>
@@ -4472,7 +4520,7 @@
           <p:cNvPr id="14" name="灯片编号占位符 1">
             <a:extLst xmlns:a="http://schemas.openxmlformats.org/drawingml/2006/main">
               <a:ext uri="{FF2B5EF4-FFF2-40B4-BE49-F238E27FC236}">
-                <a16:creationId xmlns:a16="http://schemas.microsoft.com/office/drawing/2014/main" id="{772BF290-0CF6-4B6D-BC76-906A8AF38302}"/>
+                <a16:creationId xmlns:a16="http://schemas.microsoft.com/office/drawing/2014/main" id="{A74BB00E-307E-4A5B-91BC-7A40BD533A42}"/>
               </a:ext>
             </a:extLst>
           </p:cNvPr>
@@ -4588,7 +4636,7 @@
           <p:cNvPr id="15" name="文本占位符 2">
             <a:extLst xmlns:a="http://schemas.openxmlformats.org/drawingml/2006/main">
               <a:ext uri="{FF2B5EF4-FFF2-40B4-BE49-F238E27FC236}">
-                <a16:creationId xmlns:a16="http://schemas.microsoft.com/office/drawing/2014/main" id="{709EA816-A167-4F07-8607-1996ACDDD21E}"/>
+                <a16:creationId xmlns:a16="http://schemas.microsoft.com/office/drawing/2014/main" id="{7BBB684F-30B2-4467-8EEF-1591744D938B}"/>
               </a:ext>
             </a:extLst>
           </p:cNvPr>
@@ -4708,7 +4756,7 @@
           <p:cNvPr id="16" name="">
             <a:extLst xmlns:a="http://schemas.openxmlformats.org/drawingml/2006/main">
               <a:ext uri="{FF2B5EF4-FFF2-40B4-BE49-F238E27FC236}">
-                <a16:creationId xmlns:a16="http://schemas.microsoft.com/office/drawing/2014/main" id="{52AA6E3D-854C-4F20-8145-5A181E696E9F}"/>
+                <a16:creationId xmlns:a16="http://schemas.microsoft.com/office/drawing/2014/main" id="{F9C19088-678A-4071-9A6D-DDF32488F4AA}"/>
               </a:ext>
             </a:extLst>
           </p:cNvPr>
@@ -4854,7 +4902,7 @@
                 <a:ea typeface="微软雅黑"/>
                 <a:cs typeface="微软雅黑"/>
               </a:rPr>
-              <a:t>周期任务运行后可能保留负 lag，醒来时尚不 eligible。</a:t>
+              <a:t>周期任务可能带负 lag 唤醒；短 slice 无法消除暂时不可运行。</a:t>
             </a:r>
           </a:p>
         </p:txBody>
@@ -4864,7 +4912,7 @@
           <p:cNvPr id="17" name="">
             <a:extLst xmlns:a="http://schemas.openxmlformats.org/drawingml/2006/main">
               <a:ext uri="{FF2B5EF4-FFF2-40B4-BE49-F238E27FC236}">
-                <a16:creationId xmlns:a16="http://schemas.microsoft.com/office/drawing/2014/main" id="{776D7BF6-91F7-48AA-86ED-D8F1AE0ADF4E}"/>
+                <a16:creationId xmlns:a16="http://schemas.microsoft.com/office/drawing/2014/main" id="{41848336-C0A2-4784-A6E1-D2338ADCA09F}"/>
               </a:ext>
             </a:extLst>
           </p:cNvPr>
@@ -5010,7 +5058,7 @@
                 <a:ea typeface="微软雅黑"/>
                 <a:cs typeface="微软雅黑"/>
               </a:rPr>
-              <a:t>唤醒时未被选中，随后要等待当前任务请求耗尽。</a:t>
+              <a:t>4 ms QoS 上限并启用 HRTICK，将四忙等 QoS p99 降低 39.2%。</a:t>
             </a:r>
           </a:p>
         </p:txBody>
@@ -5020,7 +5068,7 @@
           <p:cNvPr id="18" name="">
             <a:extLst xmlns:a="http://schemas.openxmlformats.org/drawingml/2006/main">
               <a:ext uri="{FF2B5EF4-FFF2-40B4-BE49-F238E27FC236}">
-                <a16:creationId xmlns:a16="http://schemas.microsoft.com/office/drawing/2014/main" id="{222385E1-5A7F-48D0-94BA-0725679297F1}"/>
+                <a16:creationId xmlns:a16="http://schemas.microsoft.com/office/drawing/2014/main" id="{763C6E45-93A0-46D4-A1E8-348A23C54A06}"/>
               </a:ext>
             </a:extLst>
           </p:cNvPr>
@@ -5166,7 +5214,7 @@
                 <a:ea typeface="微软雅黑"/>
                 <a:cs typeface="微软雅黑"/>
               </a:rPr>
-              <a:t>14 ms 后台 slice 扩大等待，4 ms tick 增加离散化影响。</a:t>
+              <a:t>代价：pingpong 增加 86.9%，无 QoS 四忙等 p99 变慢。</a:t>
             </a:r>
           </a:p>
         </p:txBody>
@@ -5176,7 +5224,7 @@
           <p:cNvPr id="19" name="">
             <a:extLst xmlns:a="http://schemas.openxmlformats.org/drawingml/2006/main">
               <a:ext uri="{FF2B5EF4-FFF2-40B4-BE49-F238E27FC236}">
-                <a16:creationId xmlns:a16="http://schemas.microsoft.com/office/drawing/2014/main" id="{AAF4FB9F-9CBA-4A16-9B2B-4569322B5874}"/>
+                <a16:creationId xmlns:a16="http://schemas.microsoft.com/office/drawing/2014/main" id="{B75B8403-157B-4F8A-ABA4-0909F7FC34B7}"/>
               </a:ext>
             </a:extLst>
           </p:cNvPr>
@@ -5322,7 +5370,7 @@
                 <a:ea typeface="微软雅黑"/>
                 <a:cs typeface="微软雅黑"/>
               </a:rPr>
-              <a:t>当前映射未达到交互尾延迟优化目标。下一步先单独重测后台 slice。</a:t>
+              <a:t>该可选方案仍慢于 CFS；实机、应用链路和长期稳定性未验证。</a:t>
             </a:r>
           </a:p>
         </p:txBody>
@@ -5330,7 +5378,7 @@
     </p:spTree>
     <p:extLst>
       <p:ext uri="{BB962C8B-B14F-4D97-AF65-F5344CB8AC3E}">
-        <p14:creationId xmlns:p14="http://schemas.microsoft.com/office/powerpoint/2010/main" val="929079189"/>
+        <p14:creationId xmlns:p14="http://schemas.microsoft.com/office/powerpoint/2010/main" val="476560752"/>
       </p:ext>
     </p:extLst>
   </p:cSld>
@@ -5354,7 +5402,7 @@
           <p:cNvPr id="14" name="灯片编号占位符 1">
             <a:extLst xmlns:a="http://schemas.openxmlformats.org/drawingml/2006/main">
               <a:ext uri="{FF2B5EF4-FFF2-40B4-BE49-F238E27FC236}">
-                <a16:creationId xmlns:a16="http://schemas.microsoft.com/office/drawing/2014/main" id="{DD3EE125-7355-43B2-82A0-D1F7EDFA76D6}"/>
+                <a16:creationId xmlns:a16="http://schemas.microsoft.com/office/drawing/2014/main" id="{33CE9EC9-AB24-4588-8AE7-F5B8952C3654}"/>
               </a:ext>
             </a:extLst>
           </p:cNvPr>
@@ -5470,7 +5518,7 @@
           <p:cNvPr id="15" name="文本占位符 2">
             <a:extLst xmlns:a="http://schemas.openxmlformats.org/drawingml/2006/main">
               <a:ext uri="{FF2B5EF4-FFF2-40B4-BE49-F238E27FC236}">
-                <a16:creationId xmlns:a16="http://schemas.microsoft.com/office/drawing/2014/main" id="{D28F0D0A-EA68-4E10-B89E-23F904EF10C1}"/>
+                <a16:creationId xmlns:a16="http://schemas.microsoft.com/office/drawing/2014/main" id="{1B17550B-F6CB-48C2-9223-0FE01A369C5C}"/>
               </a:ext>
             </a:extLst>
           </p:cNvPr>
@@ -5590,7 +5638,7 @@
           <p:cNvPr id="16" name="">
             <a:extLst xmlns:a="http://schemas.openxmlformats.org/drawingml/2006/main">
               <a:ext uri="{FF2B5EF4-FFF2-40B4-BE49-F238E27FC236}">
-                <a16:creationId xmlns:a16="http://schemas.microsoft.com/office/drawing/2014/main" id="{4D9CEB4D-79A2-49A6-AA68-2DF97419453C}"/>
+                <a16:creationId xmlns:a16="http://schemas.microsoft.com/office/drawing/2014/main" id="{DB67E894-58E9-4C6A-912C-93CC142B65C0}"/>
               </a:ext>
             </a:extLst>
           </p:cNvPr>
@@ -5746,7 +5794,7 @@
           <p:cNvPr id="17" name="">
             <a:extLst xmlns:a="http://schemas.openxmlformats.org/drawingml/2006/main">
               <a:ext uri="{FF2B5EF4-FFF2-40B4-BE49-F238E27FC236}">
-                <a16:creationId xmlns:a16="http://schemas.microsoft.com/office/drawing/2014/main" id="{89C006CD-288D-4A03-AB73-DA07325278CB}"/>
+                <a16:creationId xmlns:a16="http://schemas.microsoft.com/office/drawing/2014/main" id="{3BB7FE92-12F8-4248-9CBE-9F195F5D048D}"/>
               </a:ext>
             </a:extLst>
           </p:cNvPr>
@@ -5892,7 +5940,7 @@
                 <a:ea typeface="微软雅黑"/>
                 <a:cs typeface="微软雅黑"/>
               </a:rPr>
-              <a:t>内核补丁可从指定基线重建 9 个 Linux 文件。</a:t>
+              <a:t>初版补丁可重建 9 个 Linux 快照文件；调优补丁独立提供。</a:t>
             </a:r>
           </a:p>
         </p:txBody>
@@ -5902,7 +5950,7 @@
           <p:cNvPr id="18" name="">
             <a:extLst xmlns:a="http://schemas.openxmlformats.org/drawingml/2006/main">
               <a:ext uri="{FF2B5EF4-FFF2-40B4-BE49-F238E27FC236}">
-                <a16:creationId xmlns:a16="http://schemas.microsoft.com/office/drawing/2014/main" id="{DA59A9CF-66B3-47F8-8C83-F58110834F1A}"/>
+                <a16:creationId xmlns:a16="http://schemas.microsoft.com/office/drawing/2014/main" id="{6D86EA7D-3CF4-4899-AA2B-374995676FF5}"/>
               </a:ext>
             </a:extLst>
           </p:cNvPr>
@@ -6048,7 +6096,7 @@
                 <a:ea typeface="微软雅黑"/>
                 <a:cs typeface="微软雅黑"/>
               </a:rPr>
-              <a:t>安全 QEMU 入口使用 snapshot，记录命令和输入输出哈希。</a:t>
+              <a:t>17 组完整运行日志、两个增量 Image 构建及逐项哈希已归档。</a:t>
             </a:r>
           </a:p>
         </p:txBody>
@@ -6058,7 +6106,7 @@
           <p:cNvPr id="19" name="">
             <a:extLst xmlns:a="http://schemas.openxmlformats.org/drawingml/2006/main">
               <a:ext uri="{FF2B5EF4-FFF2-40B4-BE49-F238E27FC236}">
-                <a16:creationId xmlns:a16="http://schemas.microsoft.com/office/drawing/2014/main" id="{9F5CD34C-E015-4BC7-9C15-CCBC6B024C2C}"/>
+                <a16:creationId xmlns:a16="http://schemas.microsoft.com/office/drawing/2014/main" id="{9E4718E7-7F7E-4D1B-8E7C-6E9586A26C08}"/>
               </a:ext>
             </a:extLst>
           </p:cNvPr>
@@ -6204,7 +6252,7 @@
                 <a:ea typeface="微软雅黑"/>
                 <a:cs typeface="微软雅黑"/>
               </a:rPr>
-              <a:t>六次比较日志与 QoS 日志支持复核，系统镜像需另行准备。</a:t>
+              <a:t>完整系统镜像需另行准备；原快照和初版对照保持不变。</a:t>
             </a:r>
           </a:p>
         </p:txBody>
@@ -6212,7 +6260,7 @@
     </p:spTree>
     <p:extLst>
       <p:ext uri="{BB962C8B-B14F-4D97-AF65-F5344CB8AC3E}">
-        <p14:creationId xmlns:p14="http://schemas.microsoft.com/office/powerpoint/2010/main" val="710183254"/>
+        <p14:creationId xmlns:p14="http://schemas.microsoft.com/office/powerpoint/2010/main" val="1946012869"/>
       </p:ext>
     </p:extLst>
   </p:cSld>
@@ -6236,7 +6284,7 @@
           <p:cNvPr id="14" name="灯片编号占位符 1">
             <a:extLst xmlns:a="http://schemas.openxmlformats.org/drawingml/2006/main">
               <a:ext uri="{FF2B5EF4-FFF2-40B4-BE49-F238E27FC236}">
-                <a16:creationId xmlns:a16="http://schemas.microsoft.com/office/drawing/2014/main" id="{1CC46F64-FD35-480D-942A-08D0F5083B09}"/>
+                <a16:creationId xmlns:a16="http://schemas.microsoft.com/office/drawing/2014/main" id="{5C481E72-1169-48F1-BD8A-F6A0354AF301}"/>
               </a:ext>
             </a:extLst>
           </p:cNvPr>
@@ -6352,7 +6400,7 @@
           <p:cNvPr id="15" name="文本占位符 2">
             <a:extLst xmlns:a="http://schemas.openxmlformats.org/drawingml/2006/main">
               <a:ext uri="{FF2B5EF4-FFF2-40B4-BE49-F238E27FC236}">
-                <a16:creationId xmlns:a16="http://schemas.microsoft.com/office/drawing/2014/main" id="{51AC7CC9-2740-476D-9533-891431AE17A3}"/>
+                <a16:creationId xmlns:a16="http://schemas.microsoft.com/office/drawing/2014/main" id="{00513E13-A622-458C-BDB4-3C5CD0292FB4}"/>
               </a:ext>
             </a:extLst>
           </p:cNvPr>
@@ -6461,7 +6509,7 @@
                 <a:ea typeface="微软雅黑"/>
                 <a:cs typeface="微软雅黑"/>
               </a:rPr>
-              <a:t>本版交付机制适配与验证，后续扩大性能覆盖</a:t>
+              <a:t>可选调优有改善与明确代价，部署仍需验证</a:t>
             </a:r>
             <a:endParaRPr/>
           </a:p>
@@ -6472,7 +6520,7 @@
           <p:cNvPr id="16" name="">
             <a:extLst xmlns:a="http://schemas.openxmlformats.org/drawingml/2006/main">
               <a:ext uri="{FF2B5EF4-FFF2-40B4-BE49-F238E27FC236}">
-                <a16:creationId xmlns:a16="http://schemas.microsoft.com/office/drawing/2014/main" id="{A46737D0-7765-4141-9E06-F14AA3B7581D}"/>
+                <a16:creationId xmlns:a16="http://schemas.microsoft.com/office/drawing/2014/main" id="{9C241ECA-69D8-45EB-8587-3A27488DED21}"/>
               </a:ext>
             </a:extLst>
           </p:cNvPr>
@@ -6618,7 +6666,7 @@
                 <a:ea typeface="微软雅黑"/>
                 <a:cs typeface="微软雅黑"/>
               </a:rPr>
-              <a:t>已完成可运行移植、QoS 适配和独立正确性检查。</a:t>
+              <a:t>四忙等任务加 QoS 的唤醒 p99：15.576 → 9.474 ms。</a:t>
             </a:r>
           </a:p>
         </p:txBody>
@@ -6628,7 +6676,7 @@
           <p:cNvPr id="17" name="">
             <a:extLst xmlns:a="http://schemas.openxmlformats.org/drawingml/2006/main">
               <a:ext uri="{FF2B5EF4-FFF2-40B4-BE49-F238E27FC236}">
-                <a16:creationId xmlns:a16="http://schemas.microsoft.com/office/drawing/2014/main" id="{EF74A06B-E8D0-41A2-BB09-BCF578F52CCF}"/>
+                <a16:creationId xmlns:a16="http://schemas.microsoft.com/office/drawing/2014/main" id="{EAC981F8-C692-4D8C-B625-A10070B41F3B}"/>
               </a:ext>
             </a:extLst>
           </p:cNvPr>
@@ -6774,7 +6822,7 @@
                 <a:ea typeface="微软雅黑"/>
                 <a:cs typeface="微软雅黑"/>
               </a:rPr>
-              <a:t>当前性能结果明确暴露长后台 slice 的尾延迟问题。</a:t>
+              <a:t>线程交接增加 86.9%，无 QoS 四忙等场景变慢。</a:t>
             </a:r>
           </a:p>
         </p:txBody>
@@ -6784,7 +6832,7 @@
           <p:cNvPr id="18" name="">
             <a:extLst xmlns:a="http://schemas.openxmlformats.org/drawingml/2006/main">
               <a:ext uri="{FF2B5EF4-FFF2-40B4-BE49-F238E27FC236}">
-                <a16:creationId xmlns:a16="http://schemas.microsoft.com/office/drawing/2014/main" id="{499779A6-AA91-4153-BE9A-00F0969CA9FC}"/>
+                <a16:creationId xmlns:a16="http://schemas.microsoft.com/office/drawing/2014/main" id="{7683E648-6F47-4075-B075-192A6753D527}"/>
               </a:ext>
             </a:extLst>
           </p:cNvPr>
@@ -6930,7 +6978,7 @@
                 <a:ea typeface="微软雅黑"/>
                 <a:cs typeface="微软雅黑"/>
               </a:rPr>
-              <a:t>先比较更短后台请求及 HRTICK，再评估更大范围的回移。</a:t>
+              <a:t>2 ms cap 未通过原 QoS 判定，保留为未定结果。</a:t>
             </a:r>
           </a:p>
         </p:txBody>
@@ -6940,7 +6988,7 @@
           <p:cNvPr id="19" name="">
             <a:extLst xmlns:a="http://schemas.openxmlformats.org/drawingml/2006/main">
               <a:ext uri="{FF2B5EF4-FFF2-40B4-BE49-F238E27FC236}">
-                <a16:creationId xmlns:a16="http://schemas.microsoft.com/office/drawing/2014/main" id="{511AE663-ED59-4DBF-8469-578B6512FD51}"/>
+                <a16:creationId xmlns:a16="http://schemas.microsoft.com/office/drawing/2014/main" id="{04867394-D45A-49E7-8610-5E6176F951A9}"/>
               </a:ext>
             </a:extLst>
           </p:cNvPr>
@@ -7086,7 +7134,7 @@
                 <a:ea typeface="微软雅黑"/>
                 <a:cs typeface="微软雅黑"/>
               </a:rPr>
-              <a:t>后续验收需要用户态链路、SMP 迁移、长稳压力和实机。</a:t>
+              <a:t>用户态 QoS、SMP、长期稳定性和实机验证仍待完成。</a:t>
             </a:r>
           </a:p>
         </p:txBody>
@@ -7094,7 +7142,7 @@
     </p:spTree>
     <p:extLst>
       <p:ext uri="{BB962C8B-B14F-4D97-AF65-F5344CB8AC3E}">
-        <p14:creationId xmlns:p14="http://schemas.microsoft.com/office/powerpoint/2010/main" val="325979932"/>
+        <p14:creationId xmlns:p14="http://schemas.microsoft.com/office/powerpoint/2010/main" val="769048708"/>
       </p:ext>
     </p:extLst>
   </p:cSld>
@@ -7125,7 +7173,7 @@
           <p:cNvPr id="17" name="文本框 8">
             <a:extLst xmlns:a="http://schemas.openxmlformats.org/drawingml/2006/main">
               <a:ext uri="{FF2B5EF4-FFF2-40B4-BE49-F238E27FC236}">
-                <a16:creationId xmlns:a16="http://schemas.microsoft.com/office/drawing/2014/main" id="{09892D43-C1E0-4B25-832F-04035F7EAA8A}"/>
+                <a16:creationId xmlns:a16="http://schemas.microsoft.com/office/drawing/2014/main" id="{B55F2227-C2A4-4E3C-AFEC-99A9C52320C6}"/>
               </a:ext>
             </a:extLst>
           </p:cNvPr>
@@ -7274,7 +7322,7 @@
           <p:cNvPr id="18" name="灯片编号占位符 2">
             <a:extLst xmlns:a="http://schemas.openxmlformats.org/drawingml/2006/main">
               <a:ext uri="{FF2B5EF4-FFF2-40B4-BE49-F238E27FC236}">
-                <a16:creationId xmlns:a16="http://schemas.microsoft.com/office/drawing/2014/main" id="{2C0EA5BE-BAAE-4642-BACA-A32E5BEC8CC8}"/>
+                <a16:creationId xmlns:a16="http://schemas.microsoft.com/office/drawing/2014/main" id="{578BE645-07CD-4846-BF11-A1EA8D7F3837}"/>
               </a:ext>
             </a:extLst>
           </p:cNvPr>
@@ -7384,7 +7432,7 @@
     </p:spTree>
     <p:extLst>
       <p:ext uri="{BB962C8B-B14F-4D97-AF65-F5344CB8AC3E}">
-        <p14:creationId xmlns:p14="http://schemas.microsoft.com/office/powerpoint/2010/main" val="1563397063"/>
+        <p14:creationId xmlns:p14="http://schemas.microsoft.com/office/powerpoint/2010/main" val="642793200"/>
       </p:ext>
     </p:extLst>
   </p:cSld>
@@ -7408,7 +7456,7 @@
           <p:cNvPr id="6" name="圆角矩形 26">
             <a:extLst xmlns:a="http://schemas.openxmlformats.org/drawingml/2006/main">
               <a:ext uri="{FF2B5EF4-FFF2-40B4-BE49-F238E27FC236}">
-                <a16:creationId xmlns:a16="http://schemas.microsoft.com/office/drawing/2014/main" id="{7843B0BC-23F9-4326-B662-F743F6869236}"/>
+                <a16:creationId xmlns:a16="http://schemas.microsoft.com/office/drawing/2014/main" id="{BDCC2195-C58A-4089-A206-3FEE6F579927}"/>
               </a:ext>
             </a:extLst>
           </p:cNvPr>
@@ -7551,7 +7599,7 @@
           <p:cNvPr id="7" name="圆角矩形 27">
             <a:extLst xmlns:a="http://schemas.openxmlformats.org/drawingml/2006/main">
               <a:ext uri="{FF2B5EF4-FFF2-40B4-BE49-F238E27FC236}">
-                <a16:creationId xmlns:a16="http://schemas.microsoft.com/office/drawing/2014/main" id="{CA39EE7E-8DC6-4AB9-B4FE-E36BBDCBF6FA}"/>
+                <a16:creationId xmlns:a16="http://schemas.microsoft.com/office/drawing/2014/main" id="{77BFB971-0EE0-49D1-9732-B7FEAE4765D5}"/>
               </a:ext>
             </a:extLst>
           </p:cNvPr>
@@ -7711,7 +7759,7 @@
           <p:cNvPr id="8" name="圆角矩形 28">
             <a:extLst xmlns:a="http://schemas.openxmlformats.org/drawingml/2006/main">
               <a:ext uri="{FF2B5EF4-FFF2-40B4-BE49-F238E27FC236}">
-                <a16:creationId xmlns:a16="http://schemas.microsoft.com/office/drawing/2014/main" id="{18FA212C-1086-4081-AFC7-EB2DEE6DA6DE}"/>
+                <a16:creationId xmlns:a16="http://schemas.microsoft.com/office/drawing/2014/main" id="{9E52322D-AA82-48FC-ABDC-12EDE92B412F}"/>
               </a:ext>
             </a:extLst>
           </p:cNvPr>
@@ -7854,7 +7902,7 @@
           <p:cNvPr id="9" name="圆角矩形 29">
             <a:extLst xmlns:a="http://schemas.openxmlformats.org/drawingml/2006/main">
               <a:ext uri="{FF2B5EF4-FFF2-40B4-BE49-F238E27FC236}">
-                <a16:creationId xmlns:a16="http://schemas.microsoft.com/office/drawing/2014/main" id="{EDAF608E-D58D-47EB-AD1F-8B3678456535}"/>
+                <a16:creationId xmlns:a16="http://schemas.microsoft.com/office/drawing/2014/main" id="{88BD9347-DDBF-4872-9266-8A3A68BC2095}"/>
               </a:ext>
             </a:extLst>
           </p:cNvPr>
@@ -8024,7 +8072,7 @@
           <p:cNvPr id="10" name="圆角矩形 30">
             <a:extLst xmlns:a="http://schemas.openxmlformats.org/drawingml/2006/main">
               <a:ext uri="{FF2B5EF4-FFF2-40B4-BE49-F238E27FC236}">
-                <a16:creationId xmlns:a16="http://schemas.microsoft.com/office/drawing/2014/main" id="{4B60D876-5AEA-4E76-812D-5F5E73B97CCA}"/>
+                <a16:creationId xmlns:a16="http://schemas.microsoft.com/office/drawing/2014/main" id="{D4C7B557-C0DE-4F98-9FC1-9BD720AC377E}"/>
               </a:ext>
             </a:extLst>
           </p:cNvPr>
@@ -8167,7 +8215,7 @@
           <p:cNvPr id="11" name="圆角矩形 44">
             <a:extLst xmlns:a="http://schemas.openxmlformats.org/drawingml/2006/main">
               <a:ext uri="{FF2B5EF4-FFF2-40B4-BE49-F238E27FC236}">
-                <a16:creationId xmlns:a16="http://schemas.microsoft.com/office/drawing/2014/main" id="{A5A50ABD-2E90-45D1-AB4A-D3CB300164F1}"/>
+                <a16:creationId xmlns:a16="http://schemas.microsoft.com/office/drawing/2014/main" id="{0FB2DD4B-FB9B-446E-A066-01F6E1C02C8D}"/>
               </a:ext>
             </a:extLst>
           </p:cNvPr>
@@ -8324,7 +8372,7 @@
           <p:cNvPr id="12" name="灯片编号占位符 2">
             <a:extLst xmlns:a="http://schemas.openxmlformats.org/drawingml/2006/main">
               <a:ext uri="{FF2B5EF4-FFF2-40B4-BE49-F238E27FC236}">
-                <a16:creationId xmlns:a16="http://schemas.microsoft.com/office/drawing/2014/main" id="{928C5705-0CB5-4F89-B914-D5E3BEC8E379}"/>
+                <a16:creationId xmlns:a16="http://schemas.microsoft.com/office/drawing/2014/main" id="{2644CE08-2F1A-4686-A24B-E376797567C2}"/>
               </a:ext>
             </a:extLst>
           </p:cNvPr>
@@ -8434,7 +8482,7 @@
     </p:spTree>
     <p:extLst>
       <p:ext uri="{BB962C8B-B14F-4D97-AF65-F5344CB8AC3E}">
-        <p14:creationId xmlns:p14="http://schemas.microsoft.com/office/powerpoint/2010/main" val="715207473"/>
+        <p14:creationId xmlns:p14="http://schemas.microsoft.com/office/powerpoint/2010/main" val="2122030148"/>
       </p:ext>
     </p:extLst>
   </p:cSld>
@@ -8458,7 +8506,7 @@
           <p:cNvPr id="14" name="灯片编号占位符 1">
             <a:extLst xmlns:a="http://schemas.openxmlformats.org/drawingml/2006/main">
               <a:ext uri="{FF2B5EF4-FFF2-40B4-BE49-F238E27FC236}">
-                <a16:creationId xmlns:a16="http://schemas.microsoft.com/office/drawing/2014/main" id="{8F789D69-6E52-44C3-827E-043C9DB28107}"/>
+                <a16:creationId xmlns:a16="http://schemas.microsoft.com/office/drawing/2014/main" id="{BDB20618-E264-4A1D-B54A-2EC1BA87AF3B}"/>
               </a:ext>
             </a:extLst>
           </p:cNvPr>
@@ -8574,7 +8622,7 @@
           <p:cNvPr id="15" name="文本占位符 2">
             <a:extLst xmlns:a="http://schemas.openxmlformats.org/drawingml/2006/main">
               <a:ext uri="{FF2B5EF4-FFF2-40B4-BE49-F238E27FC236}">
-                <a16:creationId xmlns:a16="http://schemas.microsoft.com/office/drawing/2014/main" id="{982CBB70-344C-4A33-A6A1-6578020495C1}"/>
+                <a16:creationId xmlns:a16="http://schemas.microsoft.com/office/drawing/2014/main" id="{089C7E0F-A4E1-487C-A709-42D5ABC33489}"/>
               </a:ext>
             </a:extLst>
           </p:cNvPr>
@@ -8694,7 +8742,7 @@
           <p:cNvPr id="16" name="">
             <a:extLst xmlns:a="http://schemas.openxmlformats.org/drawingml/2006/main">
               <a:ext uri="{FF2B5EF4-FFF2-40B4-BE49-F238E27FC236}">
-                <a16:creationId xmlns:a16="http://schemas.microsoft.com/office/drawing/2014/main" id="{225E9C1B-34AE-4459-92F2-180A75237A4E}"/>
+                <a16:creationId xmlns:a16="http://schemas.microsoft.com/office/drawing/2014/main" id="{4284AEEF-E8E7-4350-9C75-79EC929CDA51}"/>
               </a:ext>
             </a:extLst>
           </p:cNvPr>
@@ -8850,7 +8898,7 @@
           <p:cNvPr id="17" name="">
             <a:extLst xmlns:a="http://schemas.openxmlformats.org/drawingml/2006/main">
               <a:ext uri="{FF2B5EF4-FFF2-40B4-BE49-F238E27FC236}">
-                <a16:creationId xmlns:a16="http://schemas.microsoft.com/office/drawing/2014/main" id="{65A8F0EF-F21A-4DCB-B055-DF57E07516E1}"/>
+                <a16:creationId xmlns:a16="http://schemas.microsoft.com/office/drawing/2014/main" id="{8D21B98F-1B21-4417-9B58-C88D128EEE3C}"/>
               </a:ext>
             </a:extLst>
           </p:cNvPr>
@@ -9006,7 +9054,7 @@
           <p:cNvPr id="18" name="">
             <a:extLst xmlns:a="http://schemas.openxmlformats.org/drawingml/2006/main">
               <a:ext uri="{FF2B5EF4-FFF2-40B4-BE49-F238E27FC236}">
-                <a16:creationId xmlns:a16="http://schemas.microsoft.com/office/drawing/2014/main" id="{A0AA369E-BD80-48D7-AD08-0D578679874B}"/>
+                <a16:creationId xmlns:a16="http://schemas.microsoft.com/office/drawing/2014/main" id="{44C8E230-7398-4197-B840-5532C661B028}"/>
               </a:ext>
             </a:extLst>
           </p:cNvPr>
@@ -9162,7 +9210,7 @@
           <p:cNvPr id="19" name="">
             <a:extLst xmlns:a="http://schemas.openxmlformats.org/drawingml/2006/main">
               <a:ext uri="{FF2B5EF4-FFF2-40B4-BE49-F238E27FC236}">
-                <a16:creationId xmlns:a16="http://schemas.microsoft.com/office/drawing/2014/main" id="{E87BDA57-823C-46BD-96FF-56685FCC264D}"/>
+                <a16:creationId xmlns:a16="http://schemas.microsoft.com/office/drawing/2014/main" id="{28DA290B-63B2-4FC7-BAE3-B84A2B80E016}"/>
               </a:ext>
             </a:extLst>
           </p:cNvPr>
@@ -9316,7 +9364,7 @@
     </p:spTree>
     <p:extLst>
       <p:ext uri="{BB962C8B-B14F-4D97-AF65-F5344CB8AC3E}">
-        <p14:creationId xmlns:p14="http://schemas.microsoft.com/office/powerpoint/2010/main" val="971444810"/>
+        <p14:creationId xmlns:p14="http://schemas.microsoft.com/office/powerpoint/2010/main" val="820040121"/>
       </p:ext>
     </p:extLst>
   </p:cSld>
@@ -9340,7 +9388,7 @@
           <p:cNvPr id="14" name="灯片编号占位符 1">
             <a:extLst xmlns:a="http://schemas.openxmlformats.org/drawingml/2006/main">
               <a:ext uri="{FF2B5EF4-FFF2-40B4-BE49-F238E27FC236}">
-                <a16:creationId xmlns:a16="http://schemas.microsoft.com/office/drawing/2014/main" id="{E2C2C407-F143-4792-B10D-57B498E54743}"/>
+                <a16:creationId xmlns:a16="http://schemas.microsoft.com/office/drawing/2014/main" id="{16AF7B09-7000-413C-ACC7-136F65D548C8}"/>
               </a:ext>
             </a:extLst>
           </p:cNvPr>
@@ -9456,7 +9504,7 @@
           <p:cNvPr id="15" name="文本占位符 2">
             <a:extLst xmlns:a="http://schemas.openxmlformats.org/drawingml/2006/main">
               <a:ext uri="{FF2B5EF4-FFF2-40B4-BE49-F238E27FC236}">
-                <a16:creationId xmlns:a16="http://schemas.microsoft.com/office/drawing/2014/main" id="{6A48A7F4-90A8-4717-A679-9B84619941F7}"/>
+                <a16:creationId xmlns:a16="http://schemas.microsoft.com/office/drawing/2014/main" id="{3F582211-AE7B-4FC7-92C6-0595A8743783}"/>
               </a:ext>
             </a:extLst>
           </p:cNvPr>
@@ -9576,7 +9624,7 @@
           <p:cNvPr id="16" name="">
             <a:extLst xmlns:a="http://schemas.openxmlformats.org/drawingml/2006/main">
               <a:ext uri="{FF2B5EF4-FFF2-40B4-BE49-F238E27FC236}">
-                <a16:creationId xmlns:a16="http://schemas.microsoft.com/office/drawing/2014/main" id="{63AF006D-1DB9-42D1-A384-5D14890B3430}"/>
+                <a16:creationId xmlns:a16="http://schemas.microsoft.com/office/drawing/2014/main" id="{88784726-67FA-426F-88D5-58DB3601274D}"/>
               </a:ext>
             </a:extLst>
           </p:cNvPr>
@@ -9732,7 +9780,7 @@
           <p:cNvPr id="17" name="">
             <a:extLst xmlns:a="http://schemas.openxmlformats.org/drawingml/2006/main">
               <a:ext uri="{FF2B5EF4-FFF2-40B4-BE49-F238E27FC236}">
-                <a16:creationId xmlns:a16="http://schemas.microsoft.com/office/drawing/2014/main" id="{DD77988E-6598-4F87-A062-F26DAB5AACF5}"/>
+                <a16:creationId xmlns:a16="http://schemas.microsoft.com/office/drawing/2014/main" id="{4365D496-F711-442E-B8F5-DE3DAD7DFCA9}"/>
               </a:ext>
             </a:extLst>
           </p:cNvPr>
@@ -9888,7 +9936,7 @@
           <p:cNvPr id="18" name="">
             <a:extLst xmlns:a="http://schemas.openxmlformats.org/drawingml/2006/main">
               <a:ext uri="{FF2B5EF4-FFF2-40B4-BE49-F238E27FC236}">
-                <a16:creationId xmlns:a16="http://schemas.microsoft.com/office/drawing/2014/main" id="{81C1F606-E689-4C1F-9CF0-9781DE363257}"/>
+                <a16:creationId xmlns:a16="http://schemas.microsoft.com/office/drawing/2014/main" id="{A09D83F0-E9AF-440E-AACB-A01508CF2DBC}"/>
               </a:ext>
             </a:extLst>
           </p:cNvPr>
@@ -10044,7 +10092,7 @@
           <p:cNvPr id="19" name="">
             <a:extLst xmlns:a="http://schemas.openxmlformats.org/drawingml/2006/main">
               <a:ext uri="{FF2B5EF4-FFF2-40B4-BE49-F238E27FC236}">
-                <a16:creationId xmlns:a16="http://schemas.microsoft.com/office/drawing/2014/main" id="{E364583A-DC64-4AC5-BC95-BA02277A37A2}"/>
+                <a16:creationId xmlns:a16="http://schemas.microsoft.com/office/drawing/2014/main" id="{C4299E5F-2278-48F1-87A8-003DAE8CCEAC}"/>
               </a:ext>
             </a:extLst>
           </p:cNvPr>
@@ -10198,7 +10246,7 @@
     </p:spTree>
     <p:extLst>
       <p:ext uri="{BB962C8B-B14F-4D97-AF65-F5344CB8AC3E}">
-        <p14:creationId xmlns:p14="http://schemas.microsoft.com/office/powerpoint/2010/main" val="121405224"/>
+        <p14:creationId xmlns:p14="http://schemas.microsoft.com/office/powerpoint/2010/main" val="247740800"/>
       </p:ext>
     </p:extLst>
   </p:cSld>
@@ -10222,7 +10270,7 @@
           <p:cNvPr id="14" name="灯片编号占位符 1">
             <a:extLst xmlns:a="http://schemas.openxmlformats.org/drawingml/2006/main">
               <a:ext uri="{FF2B5EF4-FFF2-40B4-BE49-F238E27FC236}">
-                <a16:creationId xmlns:a16="http://schemas.microsoft.com/office/drawing/2014/main" id="{0E2B999A-7420-4499-AB0D-3E4CD804A3CC}"/>
+                <a16:creationId xmlns:a16="http://schemas.microsoft.com/office/drawing/2014/main" id="{F265A2EE-7551-4B77-9D13-DEECC1E33FEE}"/>
               </a:ext>
             </a:extLst>
           </p:cNvPr>
@@ -10338,7 +10386,7 @@
           <p:cNvPr id="15" name="文本占位符 2">
             <a:extLst xmlns:a="http://schemas.openxmlformats.org/drawingml/2006/main">
               <a:ext uri="{FF2B5EF4-FFF2-40B4-BE49-F238E27FC236}">
-                <a16:creationId xmlns:a16="http://schemas.microsoft.com/office/drawing/2014/main" id="{360F7F98-4FE6-48DB-BCC5-3FAE27F32C76}"/>
+                <a16:creationId xmlns:a16="http://schemas.microsoft.com/office/drawing/2014/main" id="{FDE7E105-AB34-40D6-8F8D-635FD605C153}"/>
               </a:ext>
             </a:extLst>
           </p:cNvPr>
@@ -10458,7 +10506,7 @@
           <p:cNvPr id="16" name="">
             <a:extLst xmlns:a="http://schemas.openxmlformats.org/drawingml/2006/main">
               <a:ext uri="{FF2B5EF4-FFF2-40B4-BE49-F238E27FC236}">
-                <a16:creationId xmlns:a16="http://schemas.microsoft.com/office/drawing/2014/main" id="{E4766785-A878-4AF2-A412-096FB5B5E91B}"/>
+                <a16:creationId xmlns:a16="http://schemas.microsoft.com/office/drawing/2014/main" id="{3C6F0586-DD8E-456C-BF89-2CC6ACE357D4}"/>
               </a:ext>
             </a:extLst>
           </p:cNvPr>
@@ -11433,7 +11481,7 @@
           <p:cNvPr id="17" name="">
             <a:extLst xmlns:a="http://schemas.openxmlformats.org/drawingml/2006/main">
               <a:ext uri="{FF2B5EF4-FFF2-40B4-BE49-F238E27FC236}">
-                <a16:creationId xmlns:a16="http://schemas.microsoft.com/office/drawing/2014/main" id="{E42A0C80-B0AF-4E1B-A510-0509DFDEFB0B}"/>
+                <a16:creationId xmlns:a16="http://schemas.microsoft.com/office/drawing/2014/main" id="{F3B59FAD-1383-4EEA-BA4E-05B608DCCD23}"/>
               </a:ext>
             </a:extLst>
           </p:cNvPr>
@@ -11587,7 +11635,7 @@
     </p:spTree>
     <p:extLst>
       <p:ext uri="{BB962C8B-B14F-4D97-AF65-F5344CB8AC3E}">
-        <p14:creationId xmlns:p14="http://schemas.microsoft.com/office/powerpoint/2010/main" val="617687603"/>
+        <p14:creationId xmlns:p14="http://schemas.microsoft.com/office/powerpoint/2010/main" val="455966537"/>
       </p:ext>
     </p:extLst>
   </p:cSld>
@@ -11611,7 +11659,7 @@
           <p:cNvPr id="14" name="灯片编号占位符 1">
             <a:extLst xmlns:a="http://schemas.openxmlformats.org/drawingml/2006/main">
               <a:ext uri="{FF2B5EF4-FFF2-40B4-BE49-F238E27FC236}">
-                <a16:creationId xmlns:a16="http://schemas.microsoft.com/office/drawing/2014/main" id="{DC30EE2E-0707-4C7A-8F8E-8882D36098A8}"/>
+                <a16:creationId xmlns:a16="http://schemas.microsoft.com/office/drawing/2014/main" id="{7CA0536B-F808-45F8-919A-D5C0DC216BF4}"/>
               </a:ext>
             </a:extLst>
           </p:cNvPr>
@@ -11727,7 +11775,7 @@
           <p:cNvPr id="15" name="文本占位符 2">
             <a:extLst xmlns:a="http://schemas.openxmlformats.org/drawingml/2006/main">
               <a:ext uri="{FF2B5EF4-FFF2-40B4-BE49-F238E27FC236}">
-                <a16:creationId xmlns:a16="http://schemas.microsoft.com/office/drawing/2014/main" id="{75B849FF-176F-4E9D-AAED-8928CE22E895}"/>
+                <a16:creationId xmlns:a16="http://schemas.microsoft.com/office/drawing/2014/main" id="{D708B80C-27B3-4475-B967-A1678E7B603E}"/>
               </a:ext>
             </a:extLst>
           </p:cNvPr>
@@ -11847,7 +11895,7 @@
           <p:cNvPr id="16" name="">
             <a:extLst xmlns:a="http://schemas.openxmlformats.org/drawingml/2006/main">
               <a:ext uri="{FF2B5EF4-FFF2-40B4-BE49-F238E27FC236}">
-                <a16:creationId xmlns:a16="http://schemas.microsoft.com/office/drawing/2014/main" id="{5AC536D6-547E-43E3-9646-544132432532}"/>
+                <a16:creationId xmlns:a16="http://schemas.microsoft.com/office/drawing/2014/main" id="{82108FCD-33F6-4C87-A9C1-A6F82AD40A04}"/>
               </a:ext>
             </a:extLst>
           </p:cNvPr>
@@ -12003,7 +12051,7 @@
           <p:cNvPr id="17" name="">
             <a:extLst xmlns:a="http://schemas.openxmlformats.org/drawingml/2006/main">
               <a:ext uri="{FF2B5EF4-FFF2-40B4-BE49-F238E27FC236}">
-                <a16:creationId xmlns:a16="http://schemas.microsoft.com/office/drawing/2014/main" id="{ED6D00ED-B3FA-4906-B05B-D0387D0BB97A}"/>
+                <a16:creationId xmlns:a16="http://schemas.microsoft.com/office/drawing/2014/main" id="{71383230-3F6A-45C1-AB58-D87811DDD830}"/>
               </a:ext>
             </a:extLst>
           </p:cNvPr>
@@ -12159,7 +12207,7 @@
           <p:cNvPr id="18" name="">
             <a:extLst xmlns:a="http://schemas.openxmlformats.org/drawingml/2006/main">
               <a:ext uri="{FF2B5EF4-FFF2-40B4-BE49-F238E27FC236}">
-                <a16:creationId xmlns:a16="http://schemas.microsoft.com/office/drawing/2014/main" id="{1FCD080E-0F83-4F29-B590-DDE3A950AF16}"/>
+                <a16:creationId xmlns:a16="http://schemas.microsoft.com/office/drawing/2014/main" id="{D1C82159-9C24-4077-8B79-B109EBE87678}"/>
               </a:ext>
             </a:extLst>
           </p:cNvPr>
@@ -12315,7 +12363,7 @@
           <p:cNvPr id="19" name="">
             <a:extLst xmlns:a="http://schemas.openxmlformats.org/drawingml/2006/main">
               <a:ext uri="{FF2B5EF4-FFF2-40B4-BE49-F238E27FC236}">
-                <a16:creationId xmlns:a16="http://schemas.microsoft.com/office/drawing/2014/main" id="{881C8285-231E-4EB4-BD7A-0CDEA0303130}"/>
+                <a16:creationId xmlns:a16="http://schemas.microsoft.com/office/drawing/2014/main" id="{85331C2E-4D16-4A67-BF1D-CD17546E3ECD}"/>
               </a:ext>
             </a:extLst>
           </p:cNvPr>
@@ -12469,7 +12517,7 @@
     </p:spTree>
     <p:extLst>
       <p:ext uri="{BB962C8B-B14F-4D97-AF65-F5344CB8AC3E}">
-        <p14:creationId xmlns:p14="http://schemas.microsoft.com/office/powerpoint/2010/main" val="2086164158"/>
+        <p14:creationId xmlns:p14="http://schemas.microsoft.com/office/powerpoint/2010/main" val="1257412285"/>
       </p:ext>
     </p:extLst>
   </p:cSld>
@@ -12493,7 +12541,7 @@
           <p:cNvPr id="14" name="灯片编号占位符 1">
             <a:extLst xmlns:a="http://schemas.openxmlformats.org/drawingml/2006/main">
               <a:ext uri="{FF2B5EF4-FFF2-40B4-BE49-F238E27FC236}">
-                <a16:creationId xmlns:a16="http://schemas.microsoft.com/office/drawing/2014/main" id="{4B7EC5D1-2339-40B1-9F11-90CD6386DCAB}"/>
+                <a16:creationId xmlns:a16="http://schemas.microsoft.com/office/drawing/2014/main" id="{150F6EB8-DE8A-49F9-B957-28D3279E8183}"/>
               </a:ext>
             </a:extLst>
           </p:cNvPr>
@@ -12609,7 +12657,7 @@
           <p:cNvPr id="15" name="文本占位符 2">
             <a:extLst xmlns:a="http://schemas.openxmlformats.org/drawingml/2006/main">
               <a:ext uri="{FF2B5EF4-FFF2-40B4-BE49-F238E27FC236}">
-                <a16:creationId xmlns:a16="http://schemas.microsoft.com/office/drawing/2014/main" id="{70CACCFE-AE80-424D-86A6-5A8D9B87629B}"/>
+                <a16:creationId xmlns:a16="http://schemas.microsoft.com/office/drawing/2014/main" id="{46ED3D14-7E5F-462D-9FAB-DAA4767B388F}"/>
               </a:ext>
             </a:extLst>
           </p:cNvPr>
@@ -12729,7 +12777,7 @@
           <p:cNvPr id="16" name="">
             <a:extLst xmlns:a="http://schemas.openxmlformats.org/drawingml/2006/main">
               <a:ext uri="{FF2B5EF4-FFF2-40B4-BE49-F238E27FC236}">
-                <a16:creationId xmlns:a16="http://schemas.microsoft.com/office/drawing/2014/main" id="{09CCDF55-6407-4EB5-A2B3-A2618C4D419D}"/>
+                <a16:creationId xmlns:a16="http://schemas.microsoft.com/office/drawing/2014/main" id="{21BB6548-3FB0-4097-B5F0-A6258F925BC7}"/>
               </a:ext>
             </a:extLst>
           </p:cNvPr>
@@ -13169,7 +13217,7 @@
           <p:cNvPr id="17" name="">
             <a:extLst xmlns:a="http://schemas.openxmlformats.org/drawingml/2006/main">
               <a:ext uri="{FF2B5EF4-FFF2-40B4-BE49-F238E27FC236}">
-                <a16:creationId xmlns:a16="http://schemas.microsoft.com/office/drawing/2014/main" id="{138C392F-9A2B-461D-9D74-9EC4C69B97D9}"/>
+                <a16:creationId xmlns:a16="http://schemas.microsoft.com/office/drawing/2014/main" id="{673564F9-9C84-49C8-8160-5C623498196C}"/>
               </a:ext>
             </a:extLst>
           </p:cNvPr>
@@ -13323,7 +13371,7 @@
     </p:spTree>
     <p:extLst>
       <p:ext uri="{BB962C8B-B14F-4D97-AF65-F5344CB8AC3E}">
-        <p14:creationId xmlns:p14="http://schemas.microsoft.com/office/powerpoint/2010/main" val="1894048847"/>
+        <p14:creationId xmlns:p14="http://schemas.microsoft.com/office/powerpoint/2010/main" val="1671013219"/>
       </p:ext>
     </p:extLst>
   </p:cSld>
@@ -13347,7 +13395,7 @@
           <p:cNvPr id="14" name="灯片编号占位符 1">
             <a:extLst xmlns:a="http://schemas.openxmlformats.org/drawingml/2006/main">
               <a:ext uri="{FF2B5EF4-FFF2-40B4-BE49-F238E27FC236}">
-                <a16:creationId xmlns:a16="http://schemas.microsoft.com/office/drawing/2014/main" id="{B6D920D1-6288-490F-A37E-233205EFC1CB}"/>
+                <a16:creationId xmlns:a16="http://schemas.microsoft.com/office/drawing/2014/main" id="{9EC9EE91-F077-4AE6-A07E-1D5D403B9AFA}"/>
               </a:ext>
             </a:extLst>
           </p:cNvPr>
@@ -13463,7 +13511,7 @@
           <p:cNvPr id="15" name="文本占位符 2">
             <a:extLst xmlns:a="http://schemas.openxmlformats.org/drawingml/2006/main">
               <a:ext uri="{FF2B5EF4-FFF2-40B4-BE49-F238E27FC236}">
-                <a16:creationId xmlns:a16="http://schemas.microsoft.com/office/drawing/2014/main" id="{E80FC696-C69A-4B50-B3FC-886353A313E3}"/>
+                <a16:creationId xmlns:a16="http://schemas.microsoft.com/office/drawing/2014/main" id="{B5E711A4-C6FE-4E62-89BD-802E9F1A1FAE}"/>
               </a:ext>
             </a:extLst>
           </p:cNvPr>
@@ -13583,7 +13631,7 @@
           <p:cNvPr id="16" name="">
             <a:extLst xmlns:a="http://schemas.openxmlformats.org/drawingml/2006/main">
               <a:ext uri="{FF2B5EF4-FFF2-40B4-BE49-F238E27FC236}">
-                <a16:creationId xmlns:a16="http://schemas.microsoft.com/office/drawing/2014/main" id="{60845E31-086E-48BD-9715-C6CC448F88F3}"/>
+                <a16:creationId xmlns:a16="http://schemas.microsoft.com/office/drawing/2014/main" id="{5A86DCDB-ED06-477F-925E-7DADE9ABA2E5}"/>
               </a:ext>
             </a:extLst>
           </p:cNvPr>
@@ -14093,7 +14141,7 @@
           <p:cNvPr id="17" name="">
             <a:extLst xmlns:a="http://schemas.openxmlformats.org/drawingml/2006/main">
               <a:ext uri="{FF2B5EF4-FFF2-40B4-BE49-F238E27FC236}">
-                <a16:creationId xmlns:a16="http://schemas.microsoft.com/office/drawing/2014/main" id="{CAA3785D-5964-4DF4-B5CC-AAE0A9132663}"/>
+                <a16:creationId xmlns:a16="http://schemas.microsoft.com/office/drawing/2014/main" id="{B3971EF3-E784-4EA4-BA6E-43D88B696178}"/>
               </a:ext>
             </a:extLst>
           </p:cNvPr>
@@ -14247,7 +14295,7 @@
     </p:spTree>
     <p:extLst>
       <p:ext uri="{BB962C8B-B14F-4D97-AF65-F5344CB8AC3E}">
-        <p14:creationId xmlns:p14="http://schemas.microsoft.com/office/powerpoint/2010/main" val="1260357006"/>
+        <p14:creationId xmlns:p14="http://schemas.microsoft.com/office/powerpoint/2010/main" val="686878722"/>
       </p:ext>
     </p:extLst>
   </p:cSld>
@@ -14271,7 +14319,7 @@
           <p:cNvPr id="14" name="灯片编号占位符 1">
             <a:extLst xmlns:a="http://schemas.openxmlformats.org/drawingml/2006/main">
               <a:ext uri="{FF2B5EF4-FFF2-40B4-BE49-F238E27FC236}">
-                <a16:creationId xmlns:a16="http://schemas.microsoft.com/office/drawing/2014/main" id="{38349EDE-8A3B-4DF3-8A7D-435B1966E490}"/>
+                <a16:creationId xmlns:a16="http://schemas.microsoft.com/office/drawing/2014/main" id="{C12EE8DC-47BA-4F28-986C-CD8AC79E2FF1}"/>
               </a:ext>
             </a:extLst>
           </p:cNvPr>
@@ -14387,7 +14435,7 @@
           <p:cNvPr id="15" name="文本占位符 2">
             <a:extLst xmlns:a="http://schemas.openxmlformats.org/drawingml/2006/main">
               <a:ext uri="{FF2B5EF4-FFF2-40B4-BE49-F238E27FC236}">
-                <a16:creationId xmlns:a16="http://schemas.microsoft.com/office/drawing/2014/main" id="{04CD3577-A612-443B-AA17-0CF245304936}"/>
+                <a16:creationId xmlns:a16="http://schemas.microsoft.com/office/drawing/2014/main" id="{6253714C-8FD9-4B9B-A717-F3824F649E57}"/>
               </a:ext>
             </a:extLst>
           </p:cNvPr>
@@ -14496,7 +14544,7 @@
                 <a:ea typeface="微软雅黑"/>
                 <a:cs typeface="微软雅黑"/>
               </a:rPr>
-              <a:t>当前 EEVDF 的竞争唤醒尾延迟高于 CFS</a:t>
+              <a:t>可选调优降低 QoS 竞争尾延迟，但仍高于 CFS</a:t>
             </a:r>
             <a:endParaRPr/>
           </a:p>
@@ -14507,7 +14555,7 @@
           <p:cNvPr id="16" name="Chart">
             <a:extLst xmlns:a="http://schemas.openxmlformats.org/drawingml/2006/main">
               <a:ext uri="{FF2B5EF4-FFF2-40B4-BE49-F238E27FC236}">
-                <a16:creationId xmlns:a16="http://schemas.microsoft.com/office/drawing/2014/main" id="{FA24699F-DE95-449F-97D7-2FDA1C14C358}"/>
+                <a16:creationId xmlns:a16="http://schemas.microsoft.com/office/drawing/2014/main" id="{2D28FB36-6175-4985-9EF4-F67176D3ABF1}"/>
               </a:ext>
             </a:extLst>
           </p:cNvPr>
@@ -14520,7 +14568,7 @@
         </p:xfrm>
         <a:graphic xmlns:a="http://schemas.openxmlformats.org/drawingml/2006/main">
           <a:graphicData uri="http://schemas.openxmlformats.org/drawingml/2006/chart">
-            <c:chart xmlns:r="http://schemas.openxmlformats.org/officeDocument/2006/relationships" xmlns:c="http://schemas.openxmlformats.org/drawingml/2006/chart" r:id="R1f1ed8ebbc7d4c8a"/>
+            <c:chart xmlns:r="http://schemas.openxmlformats.org/officeDocument/2006/relationships" xmlns:c="http://schemas.openxmlformats.org/drawingml/2006/chart" r:id="R2ee9b6849cc44833"/>
           </a:graphicData>
         </a:graphic>
       </p:graphicFrame>
@@ -14529,7 +14577,7 @@
           <p:cNvPr id="17" name="">
             <a:extLst xmlns:a="http://schemas.openxmlformats.org/drawingml/2006/main">
               <a:ext uri="{FF2B5EF4-FFF2-40B4-BE49-F238E27FC236}">
-                <a16:creationId xmlns:a16="http://schemas.microsoft.com/office/drawing/2014/main" id="{505809F4-4D9A-42A1-84CF-40F252444779}"/>
+                <a16:creationId xmlns:a16="http://schemas.microsoft.com/office/drawing/2014/main" id="{95F10C6C-BBA8-480A-8C18-2BB5D2C2B782}"/>
               </a:ext>
             </a:extLst>
           </p:cNvPr>
@@ -14675,7 +14723,7 @@
                 <a:ea typeface="微软雅黑"/>
                 <a:cs typeface="微软雅黑"/>
               </a:rPr>
-              <a:t>唤醒 p99，单位 ms。每种内核交替启动 3 次，按次统计取中位数。</a:t>
+              <a:t>唤醒 p99，单位 ms。条形为三次启动各自统计的中位数。线程交接由 12.4 增至 23.2 μs。</a:t>
             </a:r>
           </a:p>
         </p:txBody>
@@ -14683,7 +14731,7 @@
     </p:spTree>
     <p:extLst>
       <p:ext uri="{BB962C8B-B14F-4D97-AF65-F5344CB8AC3E}">
-        <p14:creationId xmlns:p14="http://schemas.microsoft.com/office/powerpoint/2010/main" val="916768026"/>
+        <p14:creationId xmlns:p14="http://schemas.microsoft.com/office/powerpoint/2010/main" val="214297999"/>
       </p:ext>
     </p:extLst>
   </p:cSld>

</xml_diff>